<commit_message>
feat(presentation): add github repo link and test commands to slide 10
</commit_message>
<xml_diff>
--- a/presentation/slides_apresentacao.pptx
+++ b/presentation/slides_apresentacao.pptx
@@ -3250,8 +3250,8 @@
         </p:nvSpPr>
         <p:spPr>
           <a:xfrm>
-            <a:off x="731520" y="1645920"/>
-            <a:ext cx="10698480" cy="4572000"/>
+            <a:off x="731520" y="1463040"/>
+            <a:ext cx="10698480" cy="3291840"/>
           </a:xfrm>
           <a:prstGeom prst="rect">
             <a:avLst/>
@@ -3267,11 +3267,11 @@
           <a:p>
             <a:pPr>
               <a:spcBef>
-                <a:spcPts val="1000"/>
+                <a:spcPts val="600"/>
               </a:spcBef>
             </a:pPr>
             <a:r>
-              <a:rPr b="1" sz="1400">
+              <a:rPr b="1" sz="1300">
                 <a:solidFill>
                   <a:srgbClr val="0F172A"/>
                 </a:solidFill>
@@ -3279,7 +3279,7 @@
               <a:t>Superioridade de Modelos Não-Lineares Regularizados:</a:t>
             </a:r>
             <a:r>
-              <a:rPr sz="1400">
+              <a:rPr sz="1300">
                 <a:solidFill>
                   <a:srgbClr val="334155"/>
                 </a:solidFill>
@@ -3290,11 +3290,11 @@
           <a:p>
             <a:pPr>
               <a:spcBef>
-                <a:spcPts val="1000"/>
+                <a:spcPts val="600"/>
               </a:spcBef>
             </a:pPr>
             <a:r>
-              <a:rPr b="1" sz="1400">
+              <a:rPr b="1" sz="1300">
                 <a:solidFill>
                   <a:srgbClr val="0F172A"/>
                 </a:solidFill>
@@ -3302,7 +3302,7 @@
               <a:t>A Força da Engenharia de Atributos:</a:t>
             </a:r>
             <a:r>
-              <a:rPr sz="1400">
+              <a:rPr sz="1300">
                 <a:solidFill>
                   <a:srgbClr val="334155"/>
                 </a:solidFill>
@@ -3313,11 +3313,11 @@
           <a:p>
             <a:pPr>
               <a:spcBef>
-                <a:spcPts val="1000"/>
+                <a:spcPts val="600"/>
               </a:spcBef>
             </a:pPr>
             <a:r>
-              <a:rPr b="1" sz="1400">
+              <a:rPr b="1" sz="1300">
                 <a:solidFill>
                   <a:srgbClr val="0F172A"/>
                 </a:solidFill>
@@ -3325,7 +3325,7 @@
               <a:t>Conexão com a Dissertação de Mestrado:</a:t>
             </a:r>
             <a:r>
-              <a:rPr sz="1400">
+              <a:rPr sz="1300">
                 <a:solidFill>
                   <a:srgbClr val="334155"/>
                 </a:solidFill>
@@ -3336,11 +3336,11 @@
           <a:p>
             <a:pPr>
               <a:spcBef>
-                <a:spcPts val="1000"/>
+                <a:spcPts val="600"/>
               </a:spcBef>
             </a:pPr>
             <a:r>
-              <a:rPr b="1" sz="1400">
+              <a:rPr b="1" sz="1300">
                 <a:solidFill>
                   <a:srgbClr val="0F172A"/>
                 </a:solidFill>
@@ -3348,12 +3348,97 @@
               <a:t>Arquitetura e Qualidade de Software:</a:t>
             </a:r>
             <a:r>
-              <a:rPr sz="1400">
+              <a:rPr sz="1300">
                 <a:solidFill>
                   <a:srgbClr val="334155"/>
                 </a:solidFill>
               </a:rPr>
               <a:t> Aplicação monolítica full stack em Python com POO, auditável via 7 ciclos em JSON, com cobertura de testes automatizados e zero débito técnico (Clean Code).</a:t>
+            </a:r>
+          </a:p>
+        </p:txBody>
+      </p:sp>
+      <p:sp>
+        <p:nvSpPr>
+          <p:cNvPr id="4" name="Rounded Rectangle 3"/>
+          <p:cNvSpPr/>
+          <p:nvPr/>
+        </p:nvSpPr>
+        <p:spPr>
+          <a:xfrm>
+            <a:off x="731520" y="4892040"/>
+            <a:ext cx="10698480" cy="1417320"/>
+          </a:xfrm>
+          <a:prstGeom prst="roundRect">
+            <a:avLst/>
+          </a:prstGeom>
+          <a:solidFill>
+            <a:srgbClr val="F1F5F9"/>
+          </a:solidFill>
+          <a:ln w="19050">
+            <a:solidFill>
+              <a:srgbClr val="2563EB"/>
+            </a:solidFill>
+          </a:ln>
+        </p:spPr>
+        <p:style>
+          <a:lnRef idx="1">
+            <a:schemeClr val="accent1"/>
+          </a:lnRef>
+          <a:fillRef idx="3">
+            <a:schemeClr val="accent1"/>
+          </a:fillRef>
+          <a:effectRef idx="2">
+            <a:schemeClr val="accent1"/>
+          </a:effectRef>
+          <a:fontRef idx="minor">
+            <a:schemeClr val="lt1"/>
+          </a:fontRef>
+        </p:style>
+        <p:txBody>
+          <a:bodyPr rtlCol="0" anchor="ctr" wrap="square" tIns="109728" lIns="182880" rIns="182880"/>
+          <a:lstStyle/>
+          <a:p>
+            <a:pPr algn="ctr">
+              <a:defRPr b="1" sz="1200">
+                <a:solidFill>
+                  <a:srgbClr val="0F172A"/>
+                </a:solidFill>
+              </a:defRPr>
+            </a:pPr>
+            <a:r>
+              <a:t>Repositório no GitHub (Código-Fonte Aberto, Dados, Testes e Dashboard Web):</a:t>
+            </a:r>
+          </a:p>
+          <a:p>
+            <a:pPr>
+              <a:spcBef>
+                <a:spcPts val="300"/>
+              </a:spcBef>
+            </a:pPr>
+            <a:r>
+              <a:rPr b="1" sz="1400">
+                <a:solidFill>
+                  <a:srgbClr val="2563EB"/>
+                </a:solidFill>
+                <a:hlinkClick r:id="rId2"/>
+              </a:rPr>
+              <a:t>👉 https://github.com/AldairAzevedo/energy-demand-forecast</a:t>
+            </a:r>
+          </a:p>
+          <a:p>
+            <a:pPr>
+              <a:spcBef>
+                <a:spcPts val="300"/>
+              </a:spcBef>
+              <a:defRPr sz="1050">
+                <a:solidFill>
+                  <a:srgbClr val="334155"/>
+                </a:solidFill>
+              </a:defRPr>
+            </a:pPr>
+            <a:r>
+              <a:t>Para clonar e testar localmente:  git clone https://github.com/AldairAzevedo/energy-demand-forecast.git  &amp;&amp;  python -m streamlit run src/ui/app.py</a:t>
             </a:r>
           </a:p>
         </p:txBody>

</xml_diff>

<commit_message>
feat(slides): enrich deck with physical scenarios, data variables and side notes for 10-min oral presentation
</commit_message>
<xml_diff>
--- a/presentation/slides_apresentacao.pptx
+++ b/presentation/slides_apresentacao.pptx
@@ -3267,7 +3267,7 @@
           <a:p>
             <a:pPr>
               <a:spcBef>
-                <a:spcPts val="600"/>
+                <a:spcPts val="500"/>
               </a:spcBef>
             </a:pPr>
             <a:r>
@@ -3279,18 +3279,18 @@
               <a:t>Superioridade de Modelos Não-Lineares Regularizados:</a:t>
             </a:r>
             <a:r>
-              <a:rPr sz="1300">
+              <a:rPr sz="1250">
                 <a:solidFill>
                   <a:srgbClr val="334155"/>
                 </a:solidFill>
               </a:rPr>
-              <a:t> O Kernel Gaussiano Ridge (CMU) e o Random Forest (Zenodo) atingiram R² superior a 0.71 e 0.90, demonstrando a necessidade de capturar a não-linearidade térmica.</a:t>
+              <a:t> O Kernel Gaussiano Ridge (CMU) e o Random Forest (Zenodo) atingiram R² de 0.717 e 0.900, demonstrando a necessidade de capturar a não-linearidade térmica e solar.</a:t>
             </a:r>
           </a:p>
           <a:p>
             <a:pPr>
               <a:spcBef>
-                <a:spcPts val="600"/>
+                <a:spcPts val="500"/>
               </a:spcBef>
             </a:pPr>
             <a:r>
@@ -3299,21 +3299,21 @@
                   <a:srgbClr val="0F172A"/>
                 </a:solidFill>
               </a:rPr>
-              <a:t>A Força da Engenharia de Atributos:</a:t>
-            </a:r>
-            <a:r>
-              <a:rPr sz="1300">
+              <a:t>A Força da Engenharia de Atributos Multivariada:</a:t>
+            </a:r>
+            <a:r>
+              <a:rPr sz="1250">
                 <a:solidFill>
                   <a:srgbClr val="334155"/>
                 </a:solidFill>
               </a:rPr>
-              <a:t> A inclusão de variáveis como ponto de orvalho e umidade reduziu o erro em 8.73% em relação ao uso de temperatura isolada.</a:t>
+              <a:t> A inclusão de variáveis como ponto de orvalho e vento reduziu o erro em 8.73% em relação ao uso de temperatura isolada na rede da Duquesne Light.</a:t>
             </a:r>
           </a:p>
           <a:p>
             <a:pPr>
               <a:spcBef>
-                <a:spcPts val="600"/>
+                <a:spcPts val="500"/>
               </a:spcBef>
             </a:pPr>
             <a:r>
@@ -3322,21 +3322,21 @@
                   <a:srgbClr val="0F172A"/>
                 </a:solidFill>
               </a:rPr>
-              <a:t>Conexão com a Dissertação de Mestrado:</a:t>
-            </a:r>
-            <a:r>
-              <a:rPr sz="1300">
+              <a:t>Conexão com a Dissertação de Mestrado (HEMS no Mercado Livre):</a:t>
+            </a:r>
+            <a:r>
+              <a:rPr sz="1250">
                 <a:solidFill>
                   <a:srgbClr val="334155"/>
                 </a:solidFill>
               </a:rPr>
-              <a:t> A previsão de demanda líquida desenvolvida neste trabalho constitui o módulo de inteligência central do sistema autônomo (HEMS) proposto para o Mercado Livre (Grupo B).</a:t>
+              <a:t> A previsão de demanda líquida desenvolvida neste trabalho constitui o módulo de inteligência central do sistema autônomo (HEMS) proposto para o Grupo B.</a:t>
             </a:r>
           </a:p>
           <a:p>
             <a:pPr>
               <a:spcBef>
-                <a:spcPts val="600"/>
+                <a:spcPts val="500"/>
               </a:spcBef>
             </a:pPr>
             <a:r>
@@ -3348,7 +3348,7 @@
               <a:t>Arquitetura e Qualidade de Software:</a:t>
             </a:r>
             <a:r>
-              <a:rPr sz="1300">
+              <a:rPr sz="1250">
                 <a:solidFill>
                   <a:srgbClr val="334155"/>
                 </a:solidFill>
@@ -3491,7 +3491,7 @@
               </a:defRPr>
             </a:pPr>
             <a:r>
-              <a:t>1. Contexto e Motivação na Engenharia Elétrica</a:t>
+              <a:t>1. Cenários Reais e Relevância Energética</a:t>
             </a:r>
           </a:p>
           <a:p>
@@ -3506,7 +3506,7 @@
               </a:defRPr>
             </a:pPr>
             <a:r>
-              <a:t>Fundamentos e Desafios da Descarbonização e Mercado Livre</a:t>
+              <a:t>Fundamentos Físicos dos Dois Sistemas Modelados em Python</a:t>
             </a:r>
           </a:p>
         </p:txBody>
@@ -3536,93 +3536,93 @@
           <a:p>
             <a:pPr>
               <a:spcBef>
-                <a:spcPts val="1000"/>
+                <a:spcPts val="800"/>
               </a:spcBef>
             </a:pPr>
             <a:r>
-              <a:rPr b="1" sz="1400">
+              <a:rPr b="1" sz="1350">
                 <a:solidFill>
                   <a:srgbClr val="0F172A"/>
                 </a:solidFill>
               </a:rPr>
-              <a:t>A Demanda Elétrica como Fenômeno Físico-Climático:</a:t>
-            </a:r>
-            <a:r>
-              <a:rPr sz="1400">
+              <a:t>Cenário 1 — Rede de Distribuição Metropolitana (CMU 15-884):</a:t>
+            </a:r>
+            <a:r>
+              <a:rPr sz="1300">
                 <a:solidFill>
                   <a:srgbClr val="334155"/>
                 </a:solidFill>
               </a:rPr>
-              <a:t> O consumo de energia é fortemente não-linear. Em baixas e altas temperaturas, os picos disparam (aquecimento no frio, condicionamento de ar no calor extremo).</a:t>
+              <a:t> Dados reais da concessionária Duquesne Light (Pittsburgh, EUA) cobrindo 4 anos completos (2008 a 2011) — totalizando 1.460 dias e 35.064 horas consecutivas de despacho elétrico da rede.</a:t>
             </a:r>
           </a:p>
           <a:p>
             <a:pPr>
               <a:spcBef>
-                <a:spcPts val="1000"/>
+                <a:spcPts val="800"/>
               </a:spcBef>
             </a:pPr>
             <a:r>
-              <a:rPr b="1" sz="1400">
+              <a:rPr b="1" sz="1350">
                 <a:solidFill>
                   <a:srgbClr val="0F172A"/>
                 </a:solidFill>
               </a:rPr>
-              <a:t>Transição Energética e Incerteza:</a:t>
-            </a:r>
-            <a:r>
-              <a:rPr sz="1400">
+              <a:t>A Física da Não-Linearidade Térmica:</a:t>
+            </a:r>
+            <a:r>
+              <a:rPr sz="1300">
                 <a:solidFill>
                   <a:srgbClr val="334155"/>
                 </a:solidFill>
               </a:rPr>
-              <a:t> A penetração massiva de energias renováveis (solar e eólica) transforma consumidores em 'prosumidores', exigindo modelos preditivos mais rápidos e robustos.</a:t>
+              <a:t> O consumo de energia responde à termodinâmica humana em curva em 'U': dias amenos (~60°F) têm baixa demanda, enquanto o frio rigoroso dispara o aquecimento elétrico e o calor extremo dispara o ar-condicionado.</a:t>
             </a:r>
           </a:p>
           <a:p>
             <a:pPr>
               <a:spcBef>
-                <a:spcPts val="1000"/>
+                <a:spcPts val="800"/>
               </a:spcBef>
             </a:pPr>
             <a:r>
-              <a:rPr b="1" sz="1400">
+              <a:rPr b="1" sz="1350">
                 <a:solidFill>
                   <a:srgbClr val="0F172A"/>
                 </a:solidFill>
               </a:rPr>
-              <a:t>Abertura do Mercado Livre (Grupo B):</a:t>
-            </a:r>
-            <a:r>
-              <a:rPr sz="1400">
+              <a:t>Cenário 2 — Edifício Inteligente Comercial Prosumidor (Zenodo 2025):</a:t>
+            </a:r>
+            <a:r>
+              <a:rPr sz="1300">
                 <a:solidFill>
                   <a:srgbClr val="334155"/>
                 </a:solidFill>
               </a:rPr>
-              <a:t> Pequenos consumidores e residências passam a responder a sinais horários de preço (PLD Horário), tornando a acurácia da previsão um ativo econômico vital.</a:t>
+              <a:t> Prédio com geração solar fotovoltaica instalada na cobertura (Rooftop Solar PV). Telemetria de 1 ano completo com medições a cada 5 minutos (105.120 amostras) de potência ativa, tensão, corrente, temperatura e geração solar.</a:t>
             </a:r>
           </a:p>
           <a:p>
             <a:pPr>
               <a:spcBef>
-                <a:spcPts val="1000"/>
+                <a:spcPts val="800"/>
               </a:spcBef>
             </a:pPr>
             <a:r>
-              <a:rPr b="1" sz="1400">
+              <a:rPr b="1" sz="1350">
                 <a:solidFill>
                   <a:srgbClr val="0F172A"/>
                 </a:solidFill>
               </a:rPr>
-              <a:t>Objetivo do Trabalho:</a:t>
-            </a:r>
-            <a:r>
-              <a:rPr sz="1400">
+              <a:t>Relevância para a Transição e Mercado Livre (Grupo B):</a:t>
+            </a:r>
+            <a:r>
+              <a:rPr sz="1300">
                 <a:solidFill>
                   <a:srgbClr val="334155"/>
                 </a:solidFill>
               </a:rPr>
-              <a:t> Implementar, avaliar e comparar sistematicamente modelos de regressão clássicos e modernos (CMU 15-884) e algoritmos em Smart Buildings (Zenodo 2025).</a:t>
+              <a:t> A expansão do PLD Horário e das tarifas dinâmicas exige prever com alta precisão a Demanda Líquida (Carga - Solar) para evitar multas de ultrapassagem e despachar baterias.</a:t>
             </a:r>
           </a:p>
         </p:txBody>
@@ -3690,7 +3690,7 @@
               </a:defRPr>
             </a:pPr>
             <a:r>
-              <a:t>CMU 15-884 (Item 5) – Minimização de Resíduos e Otimização Paramétrica</a:t>
+              <a:t>Otimização Paramétrica e Comportamento dos Erros no Sistema em Python</a:t>
             </a:r>
           </a:p>
         </p:txBody>
@@ -3720,70 +3720,93 @@
           <a:p>
             <a:pPr>
               <a:spcBef>
-                <a:spcPts val="1200"/>
+                <a:spcPts val="800"/>
               </a:spcBef>
             </a:pPr>
             <a:r>
-              <a:rPr b="1" sz="1400">
+              <a:rPr b="1" sz="1300">
                 <a:solidFill>
                   <a:srgbClr val="0F172A"/>
                 </a:solidFill>
               </a:rPr>
-              <a:t>Perda Quadrática (L2 - Squared Loss / Mínimos Quadrados):</a:t>
-            </a:r>
-            <a:r>
-              <a:rPr sz="1400">
+              <a:t>Variáveis Físicas do Modelo (CMU Item 5):</a:t>
+            </a:r>
+            <a:r>
+              <a:rPr sz="1250">
                 <a:solidFill>
                   <a:srgbClr val="334155"/>
                 </a:solidFill>
               </a:rPr>
-              <a:t> J(θ) = Σ (y_i - φ(x_i) θ)². Pune erros grandes de forma quadrática. Fornece solução analítica exata: θ = (Φᵀ Φ)⁻¹ Φᵀ y. Vulnerável a outliers.</a:t>
+              <a:t> Entrada (x): Temperatura máxima diária em °F. Alvo (y): Pico diário de demanda da concessionária em Gigawatts (GW). Amostras: N = 1.460 dias observados.</a:t>
             </a:r>
           </a:p>
           <a:p>
             <a:pPr>
               <a:spcBef>
-                <a:spcPts val="1200"/>
+                <a:spcPts val="800"/>
               </a:spcBef>
             </a:pPr>
             <a:r>
-              <a:rPr b="1" sz="1400">
+              <a:rPr b="1" sz="1300">
                 <a:solidFill>
                   <a:srgbClr val="0F172A"/>
                 </a:solidFill>
               </a:rPr>
-              <a:t>Perda Absoluta (L1 - Absolute Loss / LAD):</a:t>
-            </a:r>
-            <a:r>
-              <a:rPr sz="1400">
+              <a:t>Perda Quadrática (L2 — Mínimos Quadrados / Squared Loss):</a:t>
+            </a:r>
+            <a:r>
+              <a:rPr sz="1250">
                 <a:solidFill>
                   <a:srgbClr val="334155"/>
                 </a:solidFill>
               </a:rPr>
-              <a:t> J(θ) = Σ |y_i - φ(x_i) θ|. Penaliza linearmente os desvios. Otimiza a MEDIANA condicional em vez da média. Extremamente robusta a ruídos e anomalias de rede.</a:t>
+              <a:t> J(θ) = Σ (y_i - φ(x_i) θ)². Resolvida no Python por Equação Normal analítica: θ = (Φᵀ Φ)⁻¹ Φᵀ y. Supõe distribuição normal de ruídos; pune severamente erros grandes, sendo muito vulnerável a picos anômalos de consumo.</a:t>
             </a:r>
           </a:p>
           <a:p>
             <a:pPr>
               <a:spcBef>
-                <a:spcPts val="1200"/>
+                <a:spcPts val="800"/>
               </a:spcBef>
             </a:pPr>
             <a:r>
-              <a:rPr b="1" sz="1400">
+              <a:rPr b="1" sz="1300">
                 <a:solidFill>
                   <a:srgbClr val="0F172A"/>
                 </a:solidFill>
               </a:rPr>
-              <a:t>Regularização Ridge (L2 Shrinkage):</a:t>
-            </a:r>
-            <a:r>
-              <a:rPr sz="1400">
+              <a:t>Perda Absoluta (L1 — LAD Robusta / Absolute Loss):</a:t>
+            </a:r>
+            <a:r>
+              <a:rPr sz="1250">
                 <a:solidFill>
                   <a:srgbClr val="334155"/>
                 </a:solidFill>
               </a:rPr>
-              <a:t> Adiciona λ ||θ||² à função de perda para restringir a magnitude dos pesos e evitar sobreajuste (overfitting) em espaços de alta dimensão.</a:t>
+              <a:t> J(θ) = Σ |y_i - φ(x_i) θ|. Otimiza a MEDIANA condicional (distribuição Laplace). Resolvida no Python por otimização convexa direta (scipy via Powell). Extremamente robusta a feriados, anomalias e variações bruscas de carga.</a:t>
+            </a:r>
+          </a:p>
+          <a:p>
+            <a:pPr>
+              <a:spcBef>
+                <a:spcPts val="800"/>
+              </a:spcBef>
+            </a:pPr>
+            <a:r>
+              <a:rPr b="1" sz="1300">
+                <a:solidFill>
+                  <a:srgbClr val="0F172A"/>
+                </a:solidFill>
+              </a:rPr>
+              <a:t>Regularização Ridge (L2 Shrinkage com λ = 10⁻⁴):</a:t>
+            </a:r>
+            <a:r>
+              <a:rPr sz="1250">
+                <a:solidFill>
+                  <a:srgbClr val="334155"/>
+                </a:solidFill>
+              </a:rPr>
+              <a:t> Adiciona penalidade λ ||θ||² na função objetivo para restringir a norma dos pesos e evitar sobreajuste (overfitting) em transformações de alta dimensão.</a:t>
             </a:r>
           </a:p>
         </p:txBody>
@@ -3836,7 +3859,7 @@
               </a:defRPr>
             </a:pPr>
             <a:r>
-              <a:t>3. Arquitetura dos 4 Modelos Avaliados</a:t>
+              <a:t>3. Arquitetura dos 4 Modelos de Regressão</a:t>
             </a:r>
           </a:p>
           <a:p>
@@ -3851,7 +3874,7 @@
               </a:defRPr>
             </a:pPr>
             <a:r>
-              <a:t>CMU 15-884 (Item 5) – Do Linear Rígido ao Kernel Gaussiano Ridge</a:t>
+              <a:t>CMU 15-884 (Item 5) – Capacidade de Modelagem e Resposta Térmica</a:t>
             </a:r>
           </a:p>
         </p:txBody>
@@ -3885,20 +3908,20 @@
               </a:spcBef>
             </a:pPr>
             <a:r>
-              <a:rPr b="1" sz="1350">
+              <a:rPr b="1" sz="1300">
                 <a:solidFill>
                   <a:srgbClr val="0F172A"/>
                 </a:solidFill>
               </a:rPr>
-              <a:t>1. Linear Simples:</a:t>
-            </a:r>
-            <a:r>
-              <a:rPr sz="1350">
+              <a:t>1. Linear Simples [φ(x) = [1, x]]:</a:t>
+            </a:r>
+            <a:r>
+              <a:rPr sz="1250">
                 <a:solidFill>
                   <a:srgbClr val="334155"/>
                 </a:solidFill>
               </a:rPr>
-              <a:t> φ(x) = [1, x]. Linha reta rígida. Incapaz de modelar a curva em 'U' da demanda térmica (R² baixo ~ 0.11).</a:t>
+              <a:t> Linha reta rígida com pesos θ ∈ ℝ². Falha na física do problema (R² = 0.116), pois supõe erroneamente que frio e calor agem na mesma direção sobre o consumo.</a:t>
             </a:r>
           </a:p>
           <a:p>
@@ -3908,20 +3931,20 @@
               </a:spcBef>
             </a:pPr>
             <a:r>
-              <a:rPr b="1" sz="1350">
+              <a:rPr b="1" sz="1300">
                 <a:solidFill>
                   <a:srgbClr val="0F172A"/>
                 </a:solidFill>
               </a:rPr>
-              <a:t>2. Polinomial (Grau 5):</a:t>
-            </a:r>
-            <a:r>
-              <a:rPr sz="1350">
+              <a:t>2. Polinomial [φ(x) = [1, x, x², x³, x⁴, x⁵]]:</a:t>
+            </a:r>
+            <a:r>
+              <a:rPr sz="1250">
                 <a:solidFill>
                   <a:srgbClr val="334155"/>
                 </a:solidFill>
               </a:rPr>
-              <a:t> φ(x) = [1, x, x², x³, x⁴, x⁵]. Curva suave que dobra no calor e no frio (R² salta para ~ 0.71). Limitação: oscilações nas pontas térmicas.</a:t>
+              <a:t> Curva contínua suave com pesos θ ∈ ℝ⁶. Modela a elevação no frio e no calor (R² salta para 0.715). Ponto fraco: vulnerabilidade a oscilações em extremos térmicos.</a:t>
             </a:r>
           </a:p>
           <a:p>
@@ -3931,20 +3954,20 @@
               </a:spcBef>
             </a:pPr>
             <a:r>
-              <a:rPr b="1" sz="1350">
+              <a:rPr b="1" sz="1300">
                 <a:solidFill>
                   <a:srgbClr val="0F172A"/>
                 </a:solidFill>
               </a:rPr>
-              <a:t>3. Funções de Base Radial (RBF):</a:t>
-            </a:r>
-            <a:r>
-              <a:rPr sz="1350">
+              <a:t>3. Funções de Base Radial (RBF Local):</a:t>
+            </a:r>
+            <a:r>
+              <a:rPr sz="1250">
                 <a:solidFill>
                   <a:srgbClr val="334155"/>
                 </a:solidFill>
               </a:rPr>
-              <a:t> 5 sinos gaussianos espalhados com σ=20: φ_j(x) = exp(-(x - μ_j)² / (2σ²)). Captura respostas térmicas locais sem explodir nas extremidades.</a:t>
+              <a:t> 5 centros fixos μ = [20, 40, 60, 80, 100]°F com dispersão σ = 20. φ_j(x) = exp(-(x - μ_j)² / (2σ²)). Sinos gaussianos que capturam comportamentos locais sem instabilidade nas bordas (R² = 0.713).</a:t>
             </a:r>
           </a:p>
           <a:p>
@@ -3954,20 +3977,20 @@
               </a:spcBef>
             </a:pPr>
             <a:r>
-              <a:rPr b="1" sz="1350">
+              <a:rPr b="1" sz="1300">
                 <a:solidFill>
                   <a:srgbClr val="0F172A"/>
                 </a:solidFill>
               </a:rPr>
-              <a:t>4. Kernel Gaussiano com Regularização Ridge (λ=10⁻⁴):</a:t>
-            </a:r>
-            <a:r>
-              <a:rPr sz="1350">
+              <a:t>4. Kernel Gaussiano com Ridge (Dual, λ = 10⁻⁴):</a:t>
+            </a:r>
+            <a:r>
+              <a:rPr sz="1250">
                 <a:solidFill>
                   <a:srgbClr val="334155"/>
                 </a:solidFill>
               </a:rPr>
-              <a:t> Compara cada dia com todo o histórico: K(x, x') = exp(-(x - x')² / (2σ²)). Alcança o melhor R² (0.717) e menor RMSE (0.157 GW).</a:t>
+              <a:t> Formulação dual via matriz de Gram K ∈ ℝ¹⁴⁶⁰ˣ¹⁴⁶⁰, comparando cada dia contra todo o histórico. Atingiu a maior acurácia global do estudo (R² = 0.717 e menor RMSE = 0.157 GW).</a:t>
             </a:r>
           </a:p>
         </p:txBody>
@@ -4057,13 +4080,244 @@
         <p:spPr>
           <a:xfrm>
             <a:off x="731520" y="1645920"/>
-            <a:ext cx="10698480" cy="4258340"/>
+            <a:ext cx="6675120" cy="2656913"/>
           </a:xfrm>
           <a:prstGeom prst="rect">
             <a:avLst/>
           </a:prstGeom>
         </p:spPr>
       </p:pic>
+      <p:sp>
+        <p:nvSpPr>
+          <p:cNvPr id="4" name="Rounded Rectangle 3"/>
+          <p:cNvSpPr/>
+          <p:nvPr/>
+        </p:nvSpPr>
+        <p:spPr>
+          <a:xfrm>
+            <a:off x="731520" y="4434840"/>
+            <a:ext cx="6675120" cy="1874519"/>
+          </a:xfrm>
+          <a:prstGeom prst="roundRect">
+            <a:avLst/>
+          </a:prstGeom>
+          <a:solidFill>
+            <a:srgbClr val="F1F5F9"/>
+          </a:solidFill>
+          <a:ln w="15240">
+            <a:solidFill>
+              <a:srgbClr val="2563EB"/>
+            </a:solidFill>
+          </a:ln>
+        </p:spPr>
+        <p:style>
+          <a:lnRef idx="1">
+            <a:schemeClr val="accent1"/>
+          </a:lnRef>
+          <a:fillRef idx="3">
+            <a:schemeClr val="accent1"/>
+          </a:fillRef>
+          <a:effectRef idx="2">
+            <a:schemeClr val="accent1"/>
+          </a:effectRef>
+          <a:fontRef idx="minor">
+            <a:schemeClr val="lt1"/>
+          </a:fontRef>
+        </p:style>
+        <p:txBody>
+          <a:bodyPr rtlCol="0" anchor="ctr" wrap="square" tIns="91440" bIns="91440" lIns="137160" rIns="137160"/>
+          <a:lstStyle/>
+          <a:p>
+            <a:pPr algn="ctr">
+              <a:defRPr b="1" sz="1150">
+                <a:solidFill>
+                  <a:srgbClr val="0F172A"/>
+                </a:solidFill>
+              </a:defRPr>
+            </a:pPr>
+            <a:r>
+              <a:t>Tabela Oficial de Métricas Calculadas no Sistema em Python:</a:t>
+            </a:r>
+          </a:p>
+          <a:p>
+            <a:pPr>
+              <a:spcBef>
+                <a:spcPts val="300"/>
+              </a:spcBef>
+              <a:defRPr sz="1000">
+                <a:solidFill>
+                  <a:srgbClr val="334155"/>
+                </a:solidFill>
+              </a:defRPr>
+            </a:pPr>
+            <a:r>
+              <a:t>• Linear Simples (L2): RMSE = 0.278 GW | MAE = 0.226 GW | R² = 0.116 (Insuficiente)</a:t>
+            </a:r>
+            <a:br/>
+            <a:r>
+              <a:t>• Polinomial d=5 (L2): RMSE = 0.158 GW | MAE = 0.120 GW | R² = 0.715 (Excelente em U)</a:t>
+            </a:r>
+            <a:br/>
+            <a:r>
+              <a:t>• RBF 5 centros (L2): RMSE = 0.158 GW | MAE = 0.121 GW | R² = 0.713 (Estável local)</a:t>
+            </a:r>
+            <a:br/>
+            <a:r>
+              <a:t>• Kernel Gaussiano (L2): RMSE = 0.157 GW | MAE = 0.120 GW | R² = 0.717 (Campeão global)</a:t>
+            </a:r>
+            <a:br/>
+            <a:r>
+              <a:t>• Kernel Gaussiano (L1): Menor MAE de toda a suíte (0.118 GW) com máxima robustez.</a:t>
+            </a:r>
+          </a:p>
+        </p:txBody>
+      </p:sp>
+      <p:sp>
+        <p:nvSpPr>
+          <p:cNvPr id="5" name="Rounded Rectangle 4"/>
+          <p:cNvSpPr/>
+          <p:nvPr/>
+        </p:nvSpPr>
+        <p:spPr>
+          <a:xfrm>
+            <a:off x="7589520" y="1645920"/>
+            <a:ext cx="3840480" cy="4663440"/>
+          </a:xfrm>
+          <a:prstGeom prst="roundRect">
+            <a:avLst/>
+          </a:prstGeom>
+          <a:solidFill>
+            <a:srgbClr val="F8FAFC"/>
+          </a:solidFill>
+          <a:ln w="12700">
+            <a:solidFill>
+              <a:srgbClr val="CBD5E1"/>
+            </a:solidFill>
+          </a:ln>
+        </p:spPr>
+        <p:style>
+          <a:lnRef idx="1">
+            <a:schemeClr val="accent1"/>
+          </a:lnRef>
+          <a:fillRef idx="3">
+            <a:schemeClr val="accent1"/>
+          </a:fillRef>
+          <a:effectRef idx="2">
+            <a:schemeClr val="accent1"/>
+          </a:effectRef>
+          <a:fontRef idx="minor">
+            <a:schemeClr val="lt1"/>
+          </a:fontRef>
+        </p:style>
+        <p:txBody>
+          <a:bodyPr rtlCol="0" anchor="ctr" wrap="square" tIns="109728" bIns="109728" lIns="137160" rIns="137160"/>
+          <a:lstStyle/>
+          <a:p>
+            <a:pPr algn="ctr">
+              <a:defRPr b="1" sz="1200">
+                <a:solidFill>
+                  <a:srgbClr val="0F172A"/>
+                </a:solidFill>
+              </a:defRPr>
+            </a:pPr>
+            <a:r>
+              <a:t>Roteiro de Leitura Física</a:t>
+            </a:r>
+          </a:p>
+          <a:p>
+            <a:pPr>
+              <a:spcBef>
+                <a:spcPts val="500"/>
+              </a:spcBef>
+            </a:pPr>
+            <a:r>
+              <a:rPr b="1" sz="1000">
+                <a:solidFill>
+                  <a:srgbClr val="2563EB"/>
+                </a:solidFill>
+              </a:rPr>
+              <a:t>Dispersão Observada: </a:t>
+            </a:r>
+            <a:r>
+              <a:rPr sz="1000">
+                <a:solidFill>
+                  <a:srgbClr val="334155"/>
+                </a:solidFill>
+              </a:rPr>
+              <a:t>1.460 pontos cinzas registrando a demanda diária real em GW da Duquesne Light.</a:t>
+            </a:r>
+          </a:p>
+          <a:p>
+            <a:pPr>
+              <a:spcBef>
+                <a:spcPts val="500"/>
+              </a:spcBef>
+            </a:pPr>
+            <a:r>
+              <a:rPr b="1" sz="1000">
+                <a:solidFill>
+                  <a:srgbClr val="2563EB"/>
+                </a:solidFill>
+              </a:rPr>
+              <a:t>Mínimo Térmico: </a:t>
+            </a:r>
+            <a:r>
+              <a:rPr sz="1000">
+                <a:solidFill>
+                  <a:srgbClr val="334155"/>
+                </a:solidFill>
+              </a:rPr>
+              <a:t>O vale de consumo ocorre perto de 60°F (15°C); acima de 85°F a demanda atinge pico.</a:t>
+            </a:r>
+          </a:p>
+          <a:p>
+            <a:pPr>
+              <a:spcBef>
+                <a:spcPts val="500"/>
+              </a:spcBef>
+            </a:pPr>
+            <a:r>
+              <a:rPr b="1" sz="1000">
+                <a:solidFill>
+                  <a:srgbClr val="2563EB"/>
+                </a:solidFill>
+              </a:rPr>
+              <a:t>Comportamento L1 vs L2: </a:t>
+            </a:r>
+            <a:r>
+              <a:rPr sz="1000">
+                <a:solidFill>
+                  <a:srgbClr val="334155"/>
+                </a:solidFill>
+              </a:rPr>
+              <a:t>As curvas com perda L1 (tracejadas) situam-se ligeiramente abaixo de L2, ajustando à mediana típica sem serem distorcidas por dias atípicos de calor extremo.</a:t>
+            </a:r>
+          </a:p>
+          <a:p>
+            <a:pPr>
+              <a:spcBef>
+                <a:spcPts val="500"/>
+              </a:spcBef>
+            </a:pPr>
+            <a:r>
+              <a:rPr b="1" sz="1000">
+                <a:solidFill>
+                  <a:srgbClr val="2563EB"/>
+                </a:solidFill>
+              </a:rPr>
+              <a:t>Conclusão do Estudo: </a:t>
+            </a:r>
+            <a:r>
+              <a:rPr sz="1000">
+                <a:solidFill>
+                  <a:srgbClr val="334155"/>
+                </a:solidFill>
+              </a:rPr>
+              <a:t>A não-linearidade térmica é mandatória: modelos não-lineares elevam a acurácia em &gt;600%.</a:t>
+            </a:r>
+          </a:p>
+        </p:txBody>
+      </p:sp>
     </p:spTree>
   </p:cSld>
   <p:clrMapOvr>
@@ -4112,7 +4366,7 @@
               </a:defRPr>
             </a:pPr>
             <a:r>
-              <a:t>5. Higienização de Sensores e Interpolação (Q6)</a:t>
+              <a:t>5. Engenharia de Dados: Higienização e Sincronização</a:t>
             </a:r>
           </a:p>
           <a:p>
@@ -4127,7 +4381,7 @@
               </a:defRPr>
             </a:pPr>
             <a:r>
-              <a:t>CMU 15-884 (Item 6) – Tratamento de Sentinelas e Sincronização Horária</a:t>
+              <a:t>CMU 15-884 (Item 6) – Tratamento de Sensores e Alinhamento Temporal</a:t>
             </a:r>
           </a:p>
         </p:txBody>
@@ -4157,93 +4411,93 @@
           <a:p>
             <a:pPr>
               <a:spcBef>
-                <a:spcPts val="1000"/>
+                <a:spcPts val="800"/>
               </a:spcBef>
             </a:pPr>
             <a:r>
-              <a:rPr b="1" sz="1400">
+              <a:rPr b="1" sz="1300">
                 <a:solidFill>
                   <a:srgbClr val="0F172A"/>
                 </a:solidFill>
               </a:rPr>
-              <a:t>Detecção de Sentinelas (-9999):</a:t>
-            </a:r>
-            <a:r>
-              <a:rPr sz="1400">
+              <a:t>Dados Brutos de Entrada:</a:t>
+            </a:r>
+            <a:r>
+              <a:rPr sz="1250">
                 <a:solidFill>
                   <a:srgbClr val="334155"/>
                 </a:solidFill>
               </a:rPr>
-              <a:t> Sensores físicos falham e registram '-9999'. Foram detectados 100 registros sentinelas, tratados por substituição por NaN e interpolação linear temporal.</a:t>
+              <a:t> q6_demand.txt (35.064 horas de demanda da Duquesne Light em MW) e q6_weather.txt (38.765 medições meteorológicas assíncronas do Aeroporto de Pittsburgh).</a:t>
             </a:r>
           </a:p>
           <a:p>
             <a:pPr>
               <a:spcBef>
-                <a:spcPts val="1000"/>
+                <a:spcPts val="800"/>
               </a:spcBef>
             </a:pPr>
             <a:r>
-              <a:rPr b="1" sz="1400">
+              <a:rPr b="1" sz="1300">
                 <a:solidFill>
                   <a:srgbClr val="0F172A"/>
                 </a:solidFill>
               </a:rPr>
-              <a:t>Deduplicação de Timestamps:</a:t>
-            </a:r>
-            <a:r>
-              <a:rPr sz="1400">
+              <a:t>Detecção e Tratamento de Sentinelas (-9999):</a:t>
+            </a:r>
+            <a:r>
+              <a:rPr sz="1250">
                 <a:solidFill>
                   <a:srgbClr val="334155"/>
                 </a:solidFill>
               </a:rPr>
-              <a:t> Remoção de leituras duplicadas no mesmo segundo para garantir consistência cronológica estrita.</a:t>
+              <a:t> Sensores meteorológicos reais apresentam falhas reportadas como '-9999'. O módulo DataCleaner substituiu 100 medições defeituosas (18 em temp, 18 em orvalho, 18 em umidade, 20 em pressão, 26 em vento) por interpolação linear temporal contínua.</a:t>
             </a:r>
           </a:p>
           <a:p>
             <a:pPr>
               <a:spcBef>
-                <a:spcPts val="1000"/>
+                <a:spcPts val="800"/>
               </a:spcBef>
             </a:pPr>
             <a:r>
-              <a:rPr b="1" sz="1400">
+              <a:rPr b="1" sz="1300">
                 <a:solidFill>
                   <a:srgbClr val="0F172A"/>
                 </a:solidFill>
               </a:rPr>
-              <a:t>Interpolação e Sincronização Horária:</a:t>
-            </a:r>
-            <a:r>
-              <a:rPr sz="1400">
+              <a:t>Deduplicação e Sincronização Horária Exata:</a:t>
+            </a:r>
+            <a:r>
+              <a:rPr sz="1250">
                 <a:solidFill>
                   <a:srgbClr val="334155"/>
                 </a:solidFill>
               </a:rPr>
-              <a:t> As leituras climáticas assíncronas foram interpoladas linearmente para alinhar com as 35.064 horas de demanda elétrica.</a:t>
+              <a:t> Timestamps duplicados foram expurgados. Como as leituras climáticas chegavam em intervalos irregulares (a cada 45 ou 50 min), o TimeSeriesInterpolator sincronizou cada medição ao segundo zero de cada uma das 35.064 horas da carga.</a:t>
             </a:r>
           </a:p>
           <a:p>
             <a:pPr>
               <a:spcBef>
-                <a:spcPts val="1000"/>
+                <a:spcPts val="800"/>
               </a:spcBef>
             </a:pPr>
             <a:r>
-              <a:rPr b="1" sz="1400">
+              <a:rPr b="1" sz="1300">
                 <a:solidFill>
                   <a:srgbClr val="0F172A"/>
                 </a:solidFill>
               </a:rPr>
-              <a:t>Agregação Diária:</a:t>
-            </a:r>
-            <a:r>
-              <a:rPr sz="1400">
+              <a:t>Agregação Diária e Matriz de Features:</a:t>
+            </a:r>
+            <a:r>
+              <a:rPr sz="1250">
                 <a:solidFill>
                   <a:srgbClr val="334155"/>
                 </a:solidFill>
               </a:rPr>
-              <a:t> Extração da Demanda Máxima do dia (y_d) e médias climáticas para alimentação dos modelos.</a:t>
+              <a:t> Extração do pico diário de demanda elétrica (y_d em MW) e 6 atributos climáticos agregados por dia: Temp Máx, Temp Mín, Orvalho Médio, Umidade Média, Pressão e Vento.</a:t>
             </a:r>
           </a:p>
         </p:txBody>
@@ -4333,13 +4587,240 @@
         <p:spPr>
           <a:xfrm>
             <a:off x="731520" y="1645920"/>
-            <a:ext cx="10698480" cy="4257851"/>
+            <a:ext cx="6675120" cy="2656608"/>
           </a:xfrm>
           <a:prstGeom prst="rect">
             <a:avLst/>
           </a:prstGeom>
         </p:spPr>
       </p:pic>
+      <p:sp>
+        <p:nvSpPr>
+          <p:cNvPr id="4" name="Rounded Rectangle 3"/>
+          <p:cNvSpPr/>
+          <p:nvPr/>
+        </p:nvSpPr>
+        <p:spPr>
+          <a:xfrm>
+            <a:off x="731520" y="4434840"/>
+            <a:ext cx="6675120" cy="1874519"/>
+          </a:xfrm>
+          <a:prstGeom prst="roundRect">
+            <a:avLst/>
+          </a:prstGeom>
+          <a:solidFill>
+            <a:srgbClr val="F1F5F9"/>
+          </a:solidFill>
+          <a:ln w="15240">
+            <a:solidFill>
+              <a:srgbClr val="2563EB"/>
+            </a:solidFill>
+          </a:ln>
+        </p:spPr>
+        <p:style>
+          <a:lnRef idx="1">
+            <a:schemeClr val="accent1"/>
+          </a:lnRef>
+          <a:fillRef idx="3">
+            <a:schemeClr val="accent1"/>
+          </a:fillRef>
+          <a:effectRef idx="2">
+            <a:schemeClr val="accent1"/>
+          </a:effectRef>
+          <a:fontRef idx="minor">
+            <a:schemeClr val="lt1"/>
+          </a:fontRef>
+        </p:style>
+        <p:txBody>
+          <a:bodyPr rtlCol="0" anchor="ctr" wrap="square" tIns="91440" bIns="91440" lIns="137160" rIns="137160"/>
+          <a:lstStyle/>
+          <a:p>
+            <a:pPr algn="ctr">
+              <a:defRPr b="1" sz="1150">
+                <a:solidFill>
+                  <a:srgbClr val="0F172A"/>
+                </a:solidFill>
+              </a:defRPr>
+            </a:pPr>
+            <a:r>
+              <a:t>Evidência Empírica Calculada no Pipeline em Python:</a:t>
+            </a:r>
+          </a:p>
+          <a:p>
+            <a:pPr>
+              <a:spcBef>
+                <a:spcPts val="300"/>
+              </a:spcBef>
+              <a:defRPr sz="1000">
+                <a:solidFill>
+                  <a:srgbClr val="334155"/>
+                </a:solidFill>
+              </a:defRPr>
+            </a:pPr>
+            <a:r>
+              <a:t>• Modelo Univariado (T_max isolada): MSE = 19.866,54 MW² | R² = 0.509</a:t>
+            </a:r>
+            <a:br/>
+            <a:r>
+              <a:t>• Modelo Multivariado (6 Variáveis Climáticas): MSE = 18.131,88 MW² | R² = 0.552</a:t>
+            </a:r>
+            <a:br/>
+            <a:r>
+              <a:t>➔ GANHO REAL DE ACURÁCIA: REDUÇÃO DE 8.73% NO ERRO QUADRÁTICO MÉDIO (MSE).</a:t>
+            </a:r>
+            <a:br/>
+            <a:r>
+              <a:t>Comprova a tese de que a atmosfera atua de forma multivariada sobre a demanda da rede.</a:t>
+            </a:r>
+          </a:p>
+        </p:txBody>
+      </p:sp>
+      <p:sp>
+        <p:nvSpPr>
+          <p:cNvPr id="5" name="Rounded Rectangle 4"/>
+          <p:cNvSpPr/>
+          <p:nvPr/>
+        </p:nvSpPr>
+        <p:spPr>
+          <a:xfrm>
+            <a:off x="7589520" y="1645920"/>
+            <a:ext cx="3840480" cy="4663440"/>
+          </a:xfrm>
+          <a:prstGeom prst="roundRect">
+            <a:avLst/>
+          </a:prstGeom>
+          <a:solidFill>
+            <a:srgbClr val="F8FAFC"/>
+          </a:solidFill>
+          <a:ln w="12700">
+            <a:solidFill>
+              <a:srgbClr val="CBD5E1"/>
+            </a:solidFill>
+          </a:ln>
+        </p:spPr>
+        <p:style>
+          <a:lnRef idx="1">
+            <a:schemeClr val="accent1"/>
+          </a:lnRef>
+          <a:fillRef idx="3">
+            <a:schemeClr val="accent1"/>
+          </a:fillRef>
+          <a:effectRef idx="2">
+            <a:schemeClr val="accent1"/>
+          </a:effectRef>
+          <a:fontRef idx="minor">
+            <a:schemeClr val="lt1"/>
+          </a:fontRef>
+        </p:style>
+        <p:txBody>
+          <a:bodyPr rtlCol="0" anchor="ctr" wrap="square" tIns="109728" bIns="109728" lIns="137160" rIns="137160"/>
+          <a:lstStyle/>
+          <a:p>
+            <a:pPr algn="ctr">
+              <a:defRPr b="1" sz="1200">
+                <a:solidFill>
+                  <a:srgbClr val="0F172A"/>
+                </a:solidFill>
+              </a:defRPr>
+            </a:pPr>
+            <a:r>
+              <a:t>Física das Novas Variáveis</a:t>
+            </a:r>
+          </a:p>
+          <a:p>
+            <a:pPr>
+              <a:spcBef>
+                <a:spcPts val="500"/>
+              </a:spcBef>
+            </a:pPr>
+            <a:r>
+              <a:rPr b="1" sz="1000">
+                <a:solidFill>
+                  <a:srgbClr val="2563EB"/>
+                </a:solidFill>
+              </a:rPr>
+              <a:t>O Teste de Hipótese: </a:t>
+            </a:r>
+            <a:r>
+              <a:rPr sz="1000">
+                <a:solidFill>
+                  <a:srgbClr val="334155"/>
+                </a:solidFill>
+              </a:rPr>
+              <a:t>Verificar se incorporar vento, umidade e orvalho reduz o erro frente à temperatura máxima isolada.</a:t>
+            </a:r>
+          </a:p>
+          <a:p>
+            <a:pPr>
+              <a:spcBef>
+                <a:spcPts val="500"/>
+              </a:spcBef>
+            </a:pPr>
+            <a:r>
+              <a:rPr b="1" sz="1000">
+                <a:solidFill>
+                  <a:srgbClr val="2563EB"/>
+                </a:solidFill>
+              </a:rPr>
+              <a:t>Ponto de Orvalho (+0.39): </a:t>
+            </a:r>
+            <a:r>
+              <a:rPr sz="1000">
+                <a:solidFill>
+                  <a:srgbClr val="334155"/>
+                </a:solidFill>
+              </a:rPr>
+              <a:t>Expressa calor latente e umidade absoluta; sensação de abafamento eleva o uso de condicionadores de ar.</a:t>
+            </a:r>
+          </a:p>
+          <a:p>
+            <a:pPr>
+              <a:spcBef>
+                <a:spcPts val="500"/>
+              </a:spcBef>
+            </a:pPr>
+            <a:r>
+              <a:rPr b="1" sz="1000">
+                <a:solidFill>
+                  <a:srgbClr val="2563EB"/>
+                </a:solidFill>
+              </a:rPr>
+              <a:t>Velocidade do Vento (-0.14): </a:t>
+            </a:r>
+            <a:r>
+              <a:rPr sz="1000">
+                <a:solidFill>
+                  <a:srgbClr val="334155"/>
+                </a:solidFill>
+              </a:rPr>
+              <a:t>Promove convecção térmica nas fachadas e arrefecimento passivo, aliviando a carga.</a:t>
+            </a:r>
+          </a:p>
+          <a:p>
+            <a:pPr>
+              <a:spcBef>
+                <a:spcPts val="500"/>
+              </a:spcBef>
+            </a:pPr>
+            <a:r>
+              <a:rPr b="1" sz="1000">
+                <a:solidFill>
+                  <a:srgbClr val="2563EB"/>
+                </a:solidFill>
+              </a:rPr>
+              <a:t>Pressão Atmosférica: </a:t>
+            </a:r>
+            <a:r>
+              <a:rPr sz="1000">
+                <a:solidFill>
+                  <a:srgbClr val="334155"/>
+                </a:solidFill>
+              </a:rPr>
+              <a:t>Indica aproximação de tempestades e frentes frias, antecipando picos de demanda.</a:t>
+            </a:r>
+          </a:p>
+        </p:txBody>
+      </p:sp>
     </p:spTree>
   </p:cSld>
   <p:clrMapOvr>
@@ -4433,93 +4914,94 @@
           <a:p>
             <a:pPr>
               <a:spcBef>
-                <a:spcPts val="1000"/>
+                <a:spcPts val="800"/>
               </a:spcBef>
             </a:pPr>
             <a:r>
-              <a:rPr b="1" sz="1400">
+              <a:rPr b="1" sz="1300">
                 <a:solidFill>
                   <a:srgbClr val="0F172A"/>
                 </a:solidFill>
               </a:rPr>
-              <a:t>Base de Dados Real de Edifício Inteligente:</a:t>
-            </a:r>
-            <a:r>
-              <a:rPr sz="1400">
+              <a:t>Cenário Físico do Edifício Inteligente:</a:t>
+            </a:r>
+            <a:r>
+              <a:rPr sz="1250">
                 <a:solidFill>
                   <a:srgbClr val="334155"/>
                 </a:solidFill>
               </a:rPr>
-              <a:t> 1 ano completo monitorando Potência (W), Tensão (V), Corrente (A), Geração Solar FV (W) e Temperatura (°C).</a:t>
+              <a:t> Telemetria de 1 ano completo a cada 5 minutos (105.120 leituras) de Potência Ativa (W), Tensão (V), Corrente (A), Temperatura (°C) e Geração Fotovoltaica em telhado (W).</a:t>
             </a:r>
           </a:p>
           <a:p>
             <a:pPr>
               <a:spcBef>
-                <a:spcPts val="1000"/>
+                <a:spcPts val="800"/>
               </a:spcBef>
             </a:pPr>
             <a:r>
-              <a:rPr b="1" sz="1400">
+              <a:rPr b="1" sz="1300">
                 <a:solidFill>
                   <a:srgbClr val="0F172A"/>
                 </a:solidFill>
               </a:rPr>
+              <a:t>Pipeline de Modelagem no Python:</a:t>
+            </a:r>
+            <a:r>
+              <a:rPr sz="1250">
+                <a:solidFill>
+                  <a:srgbClr val="334155"/>
+                </a:solidFill>
+              </a:rPr>
+              <a:t> Agregação em 8.760 horas, defasagens temporais autoregressivas (lags t-1, t-2) e variáveis de calendário (hora do dia 0-23 e dia da semana 0-6).</a:t>
+            </a:r>
+          </a:p>
+          <a:p>
+            <a:pPr>
+              <a:spcBef>
+                <a:spcPts val="800"/>
+              </a:spcBef>
+            </a:pPr>
+            <a:r>
+              <a:rPr b="1" sz="1300">
+                <a:solidFill>
+                  <a:srgbClr val="0F172A"/>
+                </a:solidFill>
+              </a:rPr>
               <a:t>Avaliação Multi-critério da Competição:</a:t>
             </a:r>
             <a:r>
-              <a:rPr sz="1400">
+              <a:rPr sz="1250">
                 <a:solidFill>
                   <a:srgbClr val="334155"/>
                 </a:solidFill>
               </a:rPr>
-              <a:t> Avalia acurácia preditiva (RMSE, MAE, R²) e tempo computacional de execução.</a:t>
+              <a:t> Avalia conjuntamente acurácia de erro (RMSE e MAE), qualidade de ajuste (R²) e tempo de processamento computacional para viabilizar controle em tempo real.</a:t>
             </a:r>
           </a:p>
           <a:p>
             <a:pPr>
               <a:spcBef>
-                <a:spcPts val="1000"/>
+                <a:spcPts val="800"/>
               </a:spcBef>
             </a:pPr>
             <a:r>
-              <a:rPr b="1" sz="1400">
+              <a:rPr b="1" sz="1300">
                 <a:solidFill>
                   <a:srgbClr val="0F172A"/>
                 </a:solidFill>
               </a:rPr>
-              <a:t>Comparativo dos Modelos:</a:t>
-            </a:r>
-            <a:r>
-              <a:rPr sz="1400">
+              <a:t>Resultados Comparativos dos Modelos:</a:t>
+            </a:r>
+            <a:r>
+              <a:rPr sz="1250">
                 <a:solidFill>
                   <a:srgbClr val="334155"/>
                 </a:solidFill>
               </a:rPr>
-              <a:t> Ridge Linear (RMSE: 398 W, Tempo: 17 ms) vs. Random Forest (RMSE: 349 W, R²: 0.900, Tempo: 134 ms).</a:t>
-            </a:r>
-          </a:p>
-          <a:p>
-            <a:pPr>
-              <a:spcBef>
-                <a:spcPts val="1000"/>
-              </a:spcBef>
-            </a:pPr>
-            <a:r>
-              <a:rPr b="1" sz="1400">
-                <a:solidFill>
-                  <a:srgbClr val="0F172A"/>
-                </a:solidFill>
-              </a:rPr>
-              <a:t>Autoconsumo e Cobertura Solar:</a:t>
-            </a:r>
-            <a:r>
-              <a:rPr sz="1400">
-                <a:solidFill>
-                  <a:srgbClr val="334155"/>
-                </a:solidFill>
-              </a:rPr>
-              <a:t> A geração solar no telhado cobriu 13.53% de toda a energia elétrica consumida, alterando o perfil de demanda da rede.</a:t>
+              <a:t> Ridge Linear: RMSE = 398,35 W | MAE = 221,67 W | R² = 0.871 | Latência: 17,5 ms.
+ Random Forest (50 árvores): RMSE = 349,45 W | MAE = 184,12 W | R² = 0.900 | Tempo: 134,1 ms (Campeão em acurácia e capacidade de generalização).</a:t>
             </a:r>
           </a:p>
         </p:txBody>
@@ -4609,13 +5091,240 @@
         <p:spPr>
           <a:xfrm>
             <a:off x="731520" y="1645920"/>
-            <a:ext cx="10698480" cy="5667704"/>
+            <a:ext cx="6675120" cy="3536260"/>
           </a:xfrm>
           <a:prstGeom prst="rect">
             <a:avLst/>
           </a:prstGeom>
         </p:spPr>
       </p:pic>
+      <p:sp>
+        <p:nvSpPr>
+          <p:cNvPr id="4" name="Rounded Rectangle 3"/>
+          <p:cNvSpPr/>
+          <p:nvPr/>
+        </p:nvSpPr>
+        <p:spPr>
+          <a:xfrm>
+            <a:off x="731520" y="5303520"/>
+            <a:ext cx="6675120" cy="1005840"/>
+          </a:xfrm>
+          <a:prstGeom prst="roundRect">
+            <a:avLst/>
+          </a:prstGeom>
+          <a:solidFill>
+            <a:srgbClr val="F1F5F9"/>
+          </a:solidFill>
+          <a:ln w="15240">
+            <a:solidFill>
+              <a:srgbClr val="2563EB"/>
+            </a:solidFill>
+          </a:ln>
+        </p:spPr>
+        <p:style>
+          <a:lnRef idx="1">
+            <a:schemeClr val="accent1"/>
+          </a:lnRef>
+          <a:fillRef idx="3">
+            <a:schemeClr val="accent1"/>
+          </a:fillRef>
+          <a:effectRef idx="2">
+            <a:schemeClr val="accent1"/>
+          </a:effectRef>
+          <a:fontRef idx="minor">
+            <a:schemeClr val="lt1"/>
+          </a:fontRef>
+        </p:style>
+        <p:txBody>
+          <a:bodyPr rtlCol="0" anchor="ctr" wrap="square" tIns="91440" bIns="91440" lIns="137160" rIns="137160"/>
+          <a:lstStyle/>
+          <a:p>
+            <a:pPr algn="ctr">
+              <a:defRPr b="1" sz="1150">
+                <a:solidFill>
+                  <a:srgbClr val="0F172A"/>
+                </a:solidFill>
+              </a:defRPr>
+            </a:pPr>
+            <a:r>
+              <a:t>Balanço Energético Anual Calculado no Sistema em Python:</a:t>
+            </a:r>
+          </a:p>
+          <a:p>
+            <a:pPr>
+              <a:spcBef>
+                <a:spcPts val="300"/>
+              </a:spcBef>
+              <a:defRPr sz="1000">
+                <a:solidFill>
+                  <a:srgbClr val="334155"/>
+                </a:solidFill>
+              </a:defRPr>
+            </a:pPr>
+            <a:r>
+              <a:t>• Potência Média Consumida pelo Edifício: 1.909 W (1,91 kW)</a:t>
+            </a:r>
+            <a:br/>
+            <a:r>
+              <a:t>• Potência Média Gerada pelos Painéis Solares: 715 W (Pico máximo registrado: 5.993 W)</a:t>
+            </a:r>
+            <a:br/>
+            <a:r>
+              <a:t>• TAXA DE COBERTURA / AUTOCONSUMO SOLAR: 13.53% de toda a energia do edifício.</a:t>
+            </a:r>
+            <a:br/>
+            <a:r>
+              <a:t>Apresenta a formação clássica da Curva do Pato, evidenciando a necessidade de inteligência preditiva para despacho e resposta da demanda.</a:t>
+            </a:r>
+          </a:p>
+        </p:txBody>
+      </p:sp>
+      <p:sp>
+        <p:nvSpPr>
+          <p:cNvPr id="5" name="Rounded Rectangle 4"/>
+          <p:cNvSpPr/>
+          <p:nvPr/>
+        </p:nvSpPr>
+        <p:spPr>
+          <a:xfrm>
+            <a:off x="7589520" y="1645920"/>
+            <a:ext cx="3840480" cy="4663440"/>
+          </a:xfrm>
+          <a:prstGeom prst="roundRect">
+            <a:avLst/>
+          </a:prstGeom>
+          <a:solidFill>
+            <a:srgbClr val="F8FAFC"/>
+          </a:solidFill>
+          <a:ln w="12700">
+            <a:solidFill>
+              <a:srgbClr val="CBD5E1"/>
+            </a:solidFill>
+          </a:ln>
+        </p:spPr>
+        <p:style>
+          <a:lnRef idx="1">
+            <a:schemeClr val="accent1"/>
+          </a:lnRef>
+          <a:fillRef idx="3">
+            <a:schemeClr val="accent1"/>
+          </a:fillRef>
+          <a:effectRef idx="2">
+            <a:schemeClr val="accent1"/>
+          </a:effectRef>
+          <a:fontRef idx="minor">
+            <a:schemeClr val="lt1"/>
+          </a:fontRef>
+        </p:style>
+        <p:txBody>
+          <a:bodyPr rtlCol="0" anchor="ctr" wrap="square" tIns="109728" bIns="109728" lIns="137160" rIns="137160"/>
+          <a:lstStyle/>
+          <a:p>
+            <a:pPr algn="ctr">
+              <a:defRPr b="1" sz="1200">
+                <a:solidFill>
+                  <a:srgbClr val="0F172A"/>
+                </a:solidFill>
+              </a:defRPr>
+            </a:pPr>
+            <a:r>
+              <a:t>Análise Operacional</a:t>
+            </a:r>
+          </a:p>
+          <a:p>
+            <a:pPr>
+              <a:spcBef>
+                <a:spcPts val="500"/>
+              </a:spcBef>
+            </a:pPr>
+            <a:r>
+              <a:rPr b="1" sz="1000">
+                <a:solidFill>
+                  <a:srgbClr val="2563EB"/>
+                </a:solidFill>
+              </a:rPr>
+              <a:t>Demanda Líquida: </a:t>
+            </a:r>
+            <a:r>
+              <a:rPr sz="1000">
+                <a:solidFill>
+                  <a:srgbClr val="334155"/>
+                </a:solidFill>
+              </a:rPr>
+              <a:t>Calculada no sistema como P_líquida = P_consumo - P_solar. Representa a carga líquida que a rede deve atender.</a:t>
+            </a:r>
+          </a:p>
+          <a:p>
+            <a:pPr>
+              <a:spcBef>
+                <a:spcPts val="500"/>
+              </a:spcBef>
+            </a:pPr>
+            <a:r>
+              <a:rPr b="1" sz="1000">
+                <a:solidFill>
+                  <a:srgbClr val="2563EB"/>
+                </a:solidFill>
+              </a:rPr>
+              <a:t>Curva do Pato: </a:t>
+            </a:r>
+            <a:r>
+              <a:rPr sz="1000">
+                <a:solidFill>
+                  <a:srgbClr val="334155"/>
+                </a:solidFill>
+              </a:rPr>
+              <a:t>O pico solar ao meio-dia (~6 kW) afunda a demanda líquida para perto de zero; às 18h surge uma rampa de subida severa.</a:t>
+            </a:r>
+          </a:p>
+          <a:p>
+            <a:pPr>
+              <a:spcBef>
+                <a:spcPts val="500"/>
+              </a:spcBef>
+            </a:pPr>
+            <a:r>
+              <a:rPr b="1" sz="1000">
+                <a:solidFill>
+                  <a:srgbClr val="2563EB"/>
+                </a:solidFill>
+              </a:rPr>
+              <a:t>Oportunidade BESS: </a:t>
+            </a:r>
+            <a:r>
+              <a:rPr sz="1000">
+                <a:solidFill>
+                  <a:srgbClr val="334155"/>
+                </a:solidFill>
+              </a:rPr>
+              <a:t>Justifica o uso de bancos de baterias para absorver excedente solar e descarregar no horário de ponta.</a:t>
+            </a:r>
+          </a:p>
+          <a:p>
+            <a:pPr>
+              <a:spcBef>
+                <a:spcPts val="500"/>
+              </a:spcBef>
+            </a:pPr>
+            <a:r>
+              <a:rPr b="1" sz="1000">
+                <a:solidFill>
+                  <a:srgbClr val="2563EB"/>
+                </a:solidFill>
+              </a:rPr>
+              <a:t>Gestão Econômica: </a:t>
+            </a:r>
+            <a:r>
+              <a:rPr sz="1000">
+                <a:solidFill>
+                  <a:srgbClr val="334155"/>
+                </a:solidFill>
+              </a:rPr>
+              <a:t>Permite ao gestor predial no Mercado Livre evitar custos abusivos com demanda contratada.</a:t>
+            </a:r>
+          </a:p>
+        </p:txBody>
+      </p:sp>
     </p:spTree>
   </p:cSld>
   <p:clrMapOvr>

</xml_diff>

<commit_message>
feat(presentation,ui): padroniza temperatura 100% em Celsius e aprimora definicoes nos slides
</commit_message>
<xml_diff>
--- a/presentation/slides_apresentacao.pptx
+++ b/presentation/slides_apresentacao.pptx
@@ -3576,7 +3576,7 @@
                   <a:srgbClr val="334155"/>
                 </a:solidFill>
               </a:rPr>
-              <a:t> O consumo de energia responde à termodinâmica humana em curva em 'U': dias amenos (~60°F) têm baixa demanda, enquanto o frio rigoroso dispara o aquecimento elétrico e o calor extremo dispara o ar-condicionado.</a:t>
+              <a:t> O consumo de energia responde à termodinâmica humana em curva em 'U': dias amenos (~15,6°C) têm baixa demanda, enquanto o frio rigoroso (abaixo de 0°C e até -14,4°C) dispara o aquecimento e o calor intenso (acima de 29°C e até 35,0°C) dispara o ar-condicionado.</a:t>
             </a:r>
           </a:p>
           <a:p>
@@ -3720,34 +3720,57 @@
           <a:p>
             <a:pPr>
               <a:spcBef>
-                <a:spcPts val="800"/>
+                <a:spcPts val="500"/>
               </a:spcBef>
             </a:pPr>
             <a:r>
-              <a:rPr b="1" sz="1300">
+              <a:rPr b="1" sz="1200">
                 <a:solidFill>
                   <a:srgbClr val="0F172A"/>
                 </a:solidFill>
               </a:rPr>
+              <a:t>O que é um Modelo de Regressão:</a:t>
+            </a:r>
+            <a:r>
+              <a:rPr sz="1150">
+                <a:solidFill>
+                  <a:srgbClr val="334155"/>
+                </a:solidFill>
+              </a:rPr>
+              <a:t> Técnica estatística e de Machine Learning usada para investigar a relação funcional entre uma variável dependente (alvo a prever: demanda em GW) e uma ou mais variáveis independentes (preditores: temperatura máxima diária em °C).</a:t>
+            </a:r>
+          </a:p>
+          <a:p>
+            <a:pPr>
+              <a:spcBef>
+                <a:spcPts val="500"/>
+              </a:spcBef>
+            </a:pPr>
+            <a:r>
+              <a:rPr b="1" sz="1200">
+                <a:solidFill>
+                  <a:srgbClr val="0F172A"/>
+                </a:solidFill>
+              </a:rPr>
               <a:t>Variáveis Físicas do Modelo (CMU Item 5):</a:t>
             </a:r>
             <a:r>
-              <a:rPr sz="1250">
+              <a:rPr sz="1150">
                 <a:solidFill>
                   <a:srgbClr val="334155"/>
                 </a:solidFill>
               </a:rPr>
-              <a:t> Entrada (x): Temperatura máxima diária em °F. Alvo (y): Pico diário de demanda da concessionária em Gigawatts (GW). Amostras: N = 1.460 dias observados.</a:t>
+              <a:t> Entrada (x): Temperatura máxima diária em graus Celsius (°C). Alvo (y): Pico diário de demanda da concessionária em Gigawatts (GW). Histórico: N = 1.460 dias observados.</a:t>
             </a:r>
           </a:p>
           <a:p>
             <a:pPr>
               <a:spcBef>
-                <a:spcPts val="800"/>
+                <a:spcPts val="500"/>
               </a:spcBef>
             </a:pPr>
             <a:r>
-              <a:rPr b="1" sz="1300">
+              <a:rPr b="1" sz="1200">
                 <a:solidFill>
                   <a:srgbClr val="0F172A"/>
                 </a:solidFill>
@@ -3755,22 +3778,22 @@
               <a:t>Perda Quadrática (L2 — Mínimos Quadrados / Squared Loss):</a:t>
             </a:r>
             <a:r>
-              <a:rPr sz="1250">
+              <a:rPr sz="1150">
                 <a:solidFill>
                   <a:srgbClr val="334155"/>
                 </a:solidFill>
               </a:rPr>
-              <a:t> J(θ) = Σ (y_i - φ(x_i) θ)². Resolvida no Python por Equação Normal analítica: θ = (Φᵀ Φ)⁻¹ Φᵀ y. Supõe distribuição normal de ruídos; pune severamente erros grandes, sendo muito vulnerável a picos anômalos de consumo.</a:t>
+              <a:t> J(θ) = Σ (y_i - φ(x_i) θ)². Resolvida no Python por Equação Normal analítica: θ = (Φᵀ Φ)⁻¹ Φᵀ y. Supõe distribuição normal de ruídos; pune severamente erros grandes, sendo puxada para baixo por feriados ou quedas pontuais de carga.</a:t>
             </a:r>
           </a:p>
           <a:p>
             <a:pPr>
               <a:spcBef>
-                <a:spcPts val="800"/>
+                <a:spcPts val="500"/>
               </a:spcBef>
             </a:pPr>
             <a:r>
-              <a:rPr b="1" sz="1300">
+              <a:rPr b="1" sz="1200">
                 <a:solidFill>
                   <a:srgbClr val="0F172A"/>
                 </a:solidFill>
@@ -3778,22 +3801,22 @@
               <a:t>Perda Absoluta (L1 — LAD Robusta / Absolute Loss):</a:t>
             </a:r>
             <a:r>
-              <a:rPr sz="1250">
+              <a:rPr sz="1150">
                 <a:solidFill>
                   <a:srgbClr val="334155"/>
                 </a:solidFill>
               </a:rPr>
-              <a:t> J(θ) = Σ |y_i - φ(x_i) θ|. Otimiza a MEDIANA condicional (distribuição Laplace). Resolvida no Python por otimização convexa direta (scipy via Powell). Extremamente robusta a feriados, anomalias e variações bruscas de carga.</a:t>
+              <a:t> J(θ) = Σ |y_i - φ(x_i) θ|. Otimiza a MEDIANA condicional (distribuição Laplace). Resolvida no Python por otimização convexa direta (scipy via Powell). Extremamente robusta a desvios e quedas anômalas, traçando a curva da demanda típica.</a:t>
             </a:r>
           </a:p>
           <a:p>
             <a:pPr>
               <a:spcBef>
-                <a:spcPts val="800"/>
+                <a:spcPts val="500"/>
               </a:spcBef>
             </a:pPr>
             <a:r>
-              <a:rPr b="1" sz="1300">
+              <a:rPr b="1" sz="1200">
                 <a:solidFill>
                   <a:srgbClr val="0F172A"/>
                 </a:solidFill>
@@ -3801,7 +3824,7 @@
               <a:t>Regularização Ridge (L2 Shrinkage com λ = 10⁻⁴):</a:t>
             </a:r>
             <a:r>
-              <a:rPr sz="1250">
+              <a:rPr sz="1150">
                 <a:solidFill>
                   <a:srgbClr val="334155"/>
                 </a:solidFill>
@@ -3967,7 +3990,7 @@
                   <a:srgbClr val="334155"/>
                 </a:solidFill>
               </a:rPr>
-              <a:t> 5 centros fixos μ = [20, 40, 60, 80, 100]°F com dispersão σ = 20. φ_j(x) = exp(-(x - μ_j)² / (2σ²)). Sinos gaussianos que capturam comportamentos locais sem instabilidade nas bordas (R² = 0.713).</a:t>
+              <a:t> 5 centros fixos distribuídos na faixa térmica μ = [-6,7; 4,4; 15,6; 26,7; 37,8]°C com dispersão σ ≈ 11,1°C. φ_j(x) = exp(-(x - μ_j)² / (2σ²)). Sinos gaussianos que capturam comportamentos locais sem instabilidade nas bordas (R² = 0.713).</a:t>
             </a:r>
           </a:p>
           <a:p>
@@ -4136,7 +4159,7 @@
               </a:defRPr>
             </a:pPr>
             <a:r>
-              <a:t>Tabela Oficial de Métricas Calculadas no Sistema em Python:</a:t>
+              <a:t>Métricas de Acurácia Calculadas no Sistema em Python:</a:t>
             </a:r>
           </a:p>
           <a:p>
@@ -4150,6 +4173,10 @@
                 </a:solidFill>
               </a:defRPr>
             </a:pPr>
+            <a:r>
+              <a:t>• Métricas: R² = Acurácia/Explicação (0 a 1) | RMSE = Erro quadrático (GW) | MAE = Desvio médio absoluto (GW)</a:t>
+            </a:r>
+            <a:br/>
             <a:r>
               <a:t>• Linear Simples (L2): RMSE = 0.278 GW | MAE = 0.226 GW | R² = 0.116 (Insuficiente)</a:t>
             </a:r>
@@ -4267,7 +4294,7 @@
                   <a:srgbClr val="334155"/>
                 </a:solidFill>
               </a:rPr>
-              <a:t>O vale de consumo ocorre perto de 60°F (15°C); acima de 85°F a demanda atinge pico.</a:t>
+              <a:t>O vale de consumo ocorre perto de 15,6°C; acima de 29°C (chegando a 35,0°C) a demanda atinge pico.</a:t>
             </a:r>
           </a:p>
           <a:p>
@@ -4290,7 +4317,7 @@
                   <a:srgbClr val="334155"/>
                 </a:solidFill>
               </a:rPr>
-              <a:t>As curvas com perda L1 (tracejadas) situam-se ligeiramente abaixo de L2, ajustando à mediana típica sem serem distorcidas por dias atípicos de calor extremo.</a:t>
+              <a:t>As curvas com perda L1 (mediana) situam-se ligeiramente ACIMA de L2 (média), pois a perda quadrática L2 é puxada para baixo por feriados e quedas anômalas.</a:t>
             </a:r>
           </a:p>
           <a:p>

</xml_diff>

<commit_message>
feat(slides): destaca explicitamente o conceito de Modelo de Regressao e estrutura comparativo L2 vs L1 no slide 3
</commit_message>
<xml_diff>
--- a/presentation/slides_apresentacao.pptx
+++ b/presentation/slides_apresentacao.pptx
@@ -3675,7 +3675,7 @@
               </a:defRPr>
             </a:pPr>
             <a:r>
-              <a:t>2. Formulação Matemática: Funções de Perda L2 vs. L1</a:t>
+              <a:t>2. Formulação Matemática: Modelos de Regressão &amp; Perdas L2 vs. L1</a:t>
             </a:r>
           </a:p>
           <a:p>
@@ -3690,146 +3690,414 @@
               </a:defRPr>
             </a:pPr>
             <a:r>
-              <a:t>Otimização Paramétrica e Comportamento dos Erros no Sistema em Python</a:t>
-            </a:r>
-          </a:p>
-        </p:txBody>
-      </p:sp>
-      <p:sp>
-        <p:nvSpPr>
-          <p:cNvPr id="3" name="TextBox 2"/>
-          <p:cNvSpPr txBox="1"/>
+              <a:t>Conceito Fundamental, Otimização Paramétrica e Comportamento dos Erros no Python</a:t>
+            </a:r>
+          </a:p>
+        </p:txBody>
+      </p:sp>
+      <p:sp>
+        <p:nvSpPr>
+          <p:cNvPr id="3" name="Rounded Rectangle 2"/>
+          <p:cNvSpPr/>
           <p:nvPr/>
         </p:nvSpPr>
         <p:spPr>
           <a:xfrm>
-            <a:off x="731520" y="1645920"/>
-            <a:ext cx="10698480" cy="4572000"/>
+            <a:off x="731520" y="1554480"/>
+            <a:ext cx="10728655" cy="1280160"/>
           </a:xfrm>
-          <a:prstGeom prst="rect">
+          <a:prstGeom prst="roundRect">
             <a:avLst/>
           </a:prstGeom>
-          <a:noFill/>
+          <a:solidFill>
+            <a:srgbClr val="EFF6FF"/>
+          </a:solidFill>
+          <a:ln w="19050">
+            <a:solidFill>
+              <a:srgbClr val="2563EB"/>
+            </a:solidFill>
+          </a:ln>
         </p:spPr>
-        <p:txBody>
-          <a:bodyPr wrap="square">
-            <a:spAutoFit/>
-          </a:bodyPr>
-          <a:lstStyle/>
-          <a:p/>
+        <p:style>
+          <a:lnRef idx="1">
+            <a:schemeClr val="accent1"/>
+          </a:lnRef>
+          <a:fillRef idx="3">
+            <a:schemeClr val="accent1"/>
+          </a:fillRef>
+          <a:effectRef idx="2">
+            <a:schemeClr val="accent1"/>
+          </a:effectRef>
+          <a:fontRef idx="minor">
+            <a:schemeClr val="lt1"/>
+          </a:fontRef>
+        </p:style>
+        <p:txBody>
+          <a:bodyPr rtlCol="0" anchor="ctr" wrap="square" tIns="109728" bIns="91440" lIns="182880" rIns="182880"/>
+          <a:lstStyle/>
+          <a:p>
+            <a:pPr algn="ctr">
+              <a:defRPr b="1" sz="1300">
+                <a:solidFill>
+                  <a:srgbClr val="0F172A"/>
+                </a:solidFill>
+              </a:defRPr>
+            </a:pPr>
+            <a:r>
+              <a:t>O que é um Modelo de Regressão?</a:t>
+            </a:r>
+          </a:p>
           <a:p>
             <a:pPr>
               <a:spcBef>
-                <a:spcPts val="500"/>
+                <a:spcPts val="300"/>
               </a:spcBef>
-            </a:pPr>
-            <a:r>
-              <a:rPr b="1" sz="1200">
+              <a:defRPr sz="1150">
+                <a:solidFill>
+                  <a:srgbClr val="334155"/>
+                </a:solidFill>
+              </a:defRPr>
+            </a:pPr>
+            <a:r>
+              <a:t>É uma técnica estatística e de aprendizado de máquina (Machine Learning) usada para investigar a relação entre uma variável dependente (o desfecho ou valor que queremos prever) e uma ou mais variáveis independentes (os preditores ou características).</a:t>
+            </a:r>
+          </a:p>
+          <a:p>
+            <a:pPr>
+              <a:spcBef>
+                <a:spcPts val="300"/>
+              </a:spcBef>
+            </a:pPr>
+            <a:r>
+              <a:rPr b="1" sz="1050">
+                <a:solidFill>
+                  <a:srgbClr val="2563EB"/>
+                </a:solidFill>
+              </a:rPr>
+              <a:t>➔ Aplicação no Sistema (CMU Item 5): </a:t>
+            </a:r>
+            <a:r>
+              <a:rPr sz="1050">
+                <a:solidFill>
+                  <a:srgbClr val="334155"/>
+                </a:solidFill>
+              </a:rPr>
+              <a:t>Variável Dependente (y): Pico diário de demanda da rede em GW | Variável Independente (x): Temperatura máxima diária em °C | Amostras: N = 1.460 dias.</a:t>
+            </a:r>
+          </a:p>
+        </p:txBody>
+      </p:sp>
+      <p:sp>
+        <p:nvSpPr>
+          <p:cNvPr id="4" name="Rounded Rectangle 3"/>
+          <p:cNvSpPr/>
+          <p:nvPr/>
+        </p:nvSpPr>
+        <p:spPr>
+          <a:xfrm>
+            <a:off x="731520" y="2971800"/>
+            <a:ext cx="5212080" cy="3337560"/>
+          </a:xfrm>
+          <a:prstGeom prst="roundRect">
+            <a:avLst/>
+          </a:prstGeom>
+          <a:solidFill>
+            <a:srgbClr val="F8FAFC"/>
+          </a:solidFill>
+          <a:ln w="12700">
+            <a:solidFill>
+              <a:srgbClr val="CBD5E1"/>
+            </a:solidFill>
+          </a:ln>
+        </p:spPr>
+        <p:style>
+          <a:lnRef idx="1">
+            <a:schemeClr val="accent1"/>
+          </a:lnRef>
+          <a:fillRef idx="3">
+            <a:schemeClr val="accent1"/>
+          </a:fillRef>
+          <a:effectRef idx="2">
+            <a:schemeClr val="accent1"/>
+          </a:effectRef>
+          <a:fontRef idx="minor">
+            <a:schemeClr val="lt1"/>
+          </a:fontRef>
+        </p:style>
+        <p:txBody>
+          <a:bodyPr rtlCol="0" anchor="ctr" wrap="square" tIns="109728" bIns="91440" lIns="164592" rIns="164592"/>
+          <a:lstStyle/>
+          <a:p>
+            <a:pPr algn="ctr">
+              <a:defRPr b="1" sz="1200">
                 <a:solidFill>
                   <a:srgbClr val="0F172A"/>
                 </a:solidFill>
-              </a:rPr>
-              <a:t>O que é um Modelo de Regressão:</a:t>
-            </a:r>
-            <a:r>
-              <a:rPr sz="1150">
+              </a:defRPr>
+            </a:pPr>
+            <a:r>
+              <a:t>Perda Quadrática (L2 — Mínimos Quadrados / OLS)</a:t>
+            </a:r>
+          </a:p>
+          <a:p>
+            <a:pPr>
+              <a:spcBef>
+                <a:spcPts val="400"/>
+              </a:spcBef>
+            </a:pPr>
+            <a:r>
+              <a:rPr b="1" sz="1000">
+                <a:solidFill>
+                  <a:srgbClr val="2563EB"/>
+                </a:solidFill>
+              </a:rPr>
+              <a:t>Função Objetivo: </a:t>
+            </a:r>
+            <a:r>
+              <a:rPr sz="1000">
                 <a:solidFill>
                   <a:srgbClr val="334155"/>
                 </a:solidFill>
               </a:rPr>
-              <a:t> Técnica estatística e de Machine Learning usada para investigar a relação funcional entre uma variável dependente (alvo a prever: demanda em GW) e uma ou mais variáveis independentes (preditores: temperatura máxima diária em °C).</a:t>
+              <a:t>J(θ) = Σ (y_i - φ(x_i) θ)². Minimiza o erro quadrático médio em toda a amostra.</a:t>
             </a:r>
           </a:p>
           <a:p>
             <a:pPr>
               <a:spcBef>
-                <a:spcPts val="500"/>
+                <a:spcPts val="400"/>
               </a:spcBef>
             </a:pPr>
             <a:r>
-              <a:rPr b="1" sz="1200">
+              <a:rPr b="1" sz="1000">
+                <a:solidFill>
+                  <a:srgbClr val="2563EB"/>
+                </a:solidFill>
+              </a:rPr>
+              <a:t>Solução no Python: </a:t>
+            </a:r>
+            <a:r>
+              <a:rPr sz="1000">
+                <a:solidFill>
+                  <a:srgbClr val="334155"/>
+                </a:solidFill>
+              </a:rPr>
+              <a:t>Equação Normal analítica exata: θ = (Φᵀ Φ)⁻¹ Φᵀ y, executada com alta velocidade.</a:t>
+            </a:r>
+          </a:p>
+          <a:p>
+            <a:pPr>
+              <a:spcBef>
+                <a:spcPts val="400"/>
+              </a:spcBef>
+            </a:pPr>
+            <a:r>
+              <a:rPr b="1" sz="1000">
+                <a:solidFill>
+                  <a:srgbClr val="2563EB"/>
+                </a:solidFill>
+              </a:rPr>
+              <a:t>Comportamento Estatístico: </a:t>
+            </a:r>
+            <a:r>
+              <a:rPr sz="1000">
+                <a:solidFill>
+                  <a:srgbClr val="334155"/>
+                </a:solidFill>
+              </a:rPr>
+              <a:t>Estima a MÉDIA condicional da demanda dada a temperatura (distribuição Gaussiana).</a:t>
+            </a:r>
+          </a:p>
+          <a:p>
+            <a:pPr>
+              <a:spcBef>
+                <a:spcPts val="400"/>
+              </a:spcBef>
+            </a:pPr>
+            <a:r>
+              <a:rPr b="1" sz="1000">
+                <a:solidFill>
+                  <a:srgbClr val="2563EB"/>
+                </a:solidFill>
+              </a:rPr>
+              <a:t>Sensibilidade a Outliers: </a:t>
+            </a:r>
+            <a:r>
+              <a:rPr sz="1000">
+                <a:solidFill>
+                  <a:srgbClr val="334155"/>
+                </a:solidFill>
+              </a:rPr>
+              <a:t>Por elevar os erros ao quadrado, a curva é puxada para baixo por dias com quedas atípicas de consumo (feriados, pontes e paradas pontuais da rede).</a:t>
+            </a:r>
+          </a:p>
+        </p:txBody>
+      </p:sp>
+      <p:sp>
+        <p:nvSpPr>
+          <p:cNvPr id="5" name="Rounded Rectangle 4"/>
+          <p:cNvSpPr/>
+          <p:nvPr/>
+        </p:nvSpPr>
+        <p:spPr>
+          <a:xfrm>
+            <a:off x="6248095" y="2971800"/>
+            <a:ext cx="5212080" cy="3337560"/>
+          </a:xfrm>
+          <a:prstGeom prst="roundRect">
+            <a:avLst/>
+          </a:prstGeom>
+          <a:solidFill>
+            <a:srgbClr val="F8FAFC"/>
+          </a:solidFill>
+          <a:ln w="12700">
+            <a:solidFill>
+              <a:srgbClr val="CBD5E1"/>
+            </a:solidFill>
+          </a:ln>
+        </p:spPr>
+        <p:style>
+          <a:lnRef idx="1">
+            <a:schemeClr val="accent1"/>
+          </a:lnRef>
+          <a:fillRef idx="3">
+            <a:schemeClr val="accent1"/>
+          </a:fillRef>
+          <a:effectRef idx="2">
+            <a:schemeClr val="accent1"/>
+          </a:effectRef>
+          <a:fontRef idx="minor">
+            <a:schemeClr val="lt1"/>
+          </a:fontRef>
+        </p:style>
+        <p:txBody>
+          <a:bodyPr rtlCol="0" anchor="ctr" wrap="square" tIns="109728" bIns="91440" lIns="164592" rIns="164592"/>
+          <a:lstStyle/>
+          <a:p>
+            <a:pPr algn="ctr">
+              <a:defRPr b="1" sz="1200">
                 <a:solidFill>
                   <a:srgbClr val="0F172A"/>
                 </a:solidFill>
-              </a:rPr>
-              <a:t>Variáveis Físicas do Modelo (CMU Item 5):</a:t>
-            </a:r>
-            <a:r>
-              <a:rPr sz="1150">
+              </a:defRPr>
+            </a:pPr>
+            <a:r>
+              <a:t>Perda Absoluta (L1 — LAD Robusta / Powell)</a:t>
+            </a:r>
+          </a:p>
+          <a:p>
+            <a:pPr>
+              <a:spcBef>
+                <a:spcPts val="350"/>
+              </a:spcBef>
+            </a:pPr>
+            <a:r>
+              <a:rPr b="1" sz="950">
+                <a:solidFill>
+                  <a:srgbClr val="2563EB"/>
+                </a:solidFill>
+              </a:rPr>
+              <a:t>Função Objetivo: </a:t>
+            </a:r>
+            <a:r>
+              <a:rPr sz="950">
                 <a:solidFill>
                   <a:srgbClr val="334155"/>
                 </a:solidFill>
               </a:rPr>
-              <a:t> Entrada (x): Temperatura máxima diária em graus Celsius (°C). Alvo (y): Pico diário de demanda da concessionária em Gigawatts (GW). Histórico: N = 1.460 dias observados.</a:t>
+              <a:t>J(θ) = Σ |y_i - φ(x_i) θ|. Penaliza os desvios de forma linear e proporcional.</a:t>
             </a:r>
           </a:p>
           <a:p>
             <a:pPr>
               <a:spcBef>
-                <a:spcPts val="500"/>
+                <a:spcPts val="350"/>
               </a:spcBef>
             </a:pPr>
             <a:r>
-              <a:rPr b="1" sz="1200">
-                <a:solidFill>
-                  <a:srgbClr val="0F172A"/>
-                </a:solidFill>
-              </a:rPr>
-              <a:t>Perda Quadrática (L2 — Mínimos Quadrados / Squared Loss):</a:t>
-            </a:r>
-            <a:r>
-              <a:rPr sz="1150">
+              <a:rPr b="1" sz="950">
+                <a:solidFill>
+                  <a:srgbClr val="2563EB"/>
+                </a:solidFill>
+              </a:rPr>
+              <a:t>Solução no Python: </a:t>
+            </a:r>
+            <a:r>
+              <a:rPr sz="950">
                 <a:solidFill>
                   <a:srgbClr val="334155"/>
                 </a:solidFill>
               </a:rPr>
-              <a:t> J(θ) = Σ (y_i - φ(x_i) θ)². Resolvida no Python por Equação Normal analítica: θ = (Φᵀ Φ)⁻¹ Φᵀ y. Supõe distribuição normal de ruídos; pune severamente erros grandes, sendo puxada para baixo por feriados ou quedas pontuais de carga.</a:t>
+              <a:t>Otimização numérica via scipy.optimize.minimize com método Powell (sem derivada).</a:t>
             </a:r>
           </a:p>
           <a:p>
             <a:pPr>
               <a:spcBef>
-                <a:spcPts val="500"/>
+                <a:spcPts val="350"/>
               </a:spcBef>
             </a:pPr>
             <a:r>
-              <a:rPr b="1" sz="1200">
-                <a:solidFill>
-                  <a:srgbClr val="0F172A"/>
-                </a:solidFill>
-              </a:rPr>
-              <a:t>Perda Absoluta (L1 — LAD Robusta / Absolute Loss):</a:t>
-            </a:r>
-            <a:r>
-              <a:rPr sz="1150">
+              <a:rPr b="1" sz="950">
+                <a:solidFill>
+                  <a:srgbClr val="2563EB"/>
+                </a:solidFill>
+              </a:rPr>
+              <a:t>Comportamento Estatístico: </a:t>
+            </a:r>
+            <a:r>
+              <a:rPr sz="950">
                 <a:solidFill>
                   <a:srgbClr val="334155"/>
                 </a:solidFill>
               </a:rPr>
-              <a:t> J(θ) = Σ |y_i - φ(x_i) θ|. Otimiza a MEDIANA condicional (distribuição Laplace). Resolvida no Python por otimização convexa direta (scipy via Powell). Extremamente robusta a desvios e quedas anômalas, traçando a curva da demanda típica.</a:t>
+              <a:t>Estima a MEDIANA condicional da demanda (associada à distribuição de Laplace).</a:t>
             </a:r>
           </a:p>
           <a:p>
             <a:pPr>
               <a:spcBef>
-                <a:spcPts val="500"/>
+                <a:spcPts val="350"/>
               </a:spcBef>
             </a:pPr>
             <a:r>
-              <a:rPr b="1" sz="1200">
-                <a:solidFill>
-                  <a:srgbClr val="0F172A"/>
-                </a:solidFill>
-              </a:rPr>
-              <a:t>Regularização Ridge (L2 Shrinkage com λ = 10⁻⁴):</a:t>
-            </a:r>
-            <a:r>
-              <a:rPr sz="1150">
+              <a:rPr b="1" sz="950">
+                <a:solidFill>
+                  <a:srgbClr val="2563EB"/>
+                </a:solidFill>
+              </a:rPr>
+              <a:t>Máxima Robustez Física: </a:t>
+            </a:r>
+            <a:r>
+              <a:rPr sz="950">
                 <a:solidFill>
                   <a:srgbClr val="334155"/>
                 </a:solidFill>
               </a:rPr>
-              <a:t> Adiciona penalidade λ ||θ||² na função objetivo para restringir a norma dos pesos e evitar sobreajuste (overfitting) em transformações de alta dimensão.</a:t>
+              <a:t>Ignora quedas atípicas de feriados; traça o consumo típico e fica ligeiramente ACIMA de L2 no gráfico, refletindo os dias de operação plena da rede.</a:t>
+            </a:r>
+          </a:p>
+          <a:p>
+            <a:pPr>
+              <a:spcBef>
+                <a:spcPts val="350"/>
+              </a:spcBef>
+            </a:pPr>
+            <a:r>
+              <a:rPr b="1" sz="950">
+                <a:solidFill>
+                  <a:srgbClr val="2563EB"/>
+                </a:solidFill>
+              </a:rPr>
+              <a:t>Regularização Ridge (λ = 10⁻⁴): </a:t>
+            </a:r>
+            <a:r>
+              <a:rPr sz="950">
+                <a:solidFill>
+                  <a:srgbClr val="334155"/>
+                </a:solidFill>
+              </a:rPr>
+              <a:t>Penalidade λ ||θ||² incluída para evitar sobreajuste em matrizes de alta dimensão.</a:t>
             </a:r>
           </a:p>
         </p:txBody>

</xml_diff>

<commit_message>
refactor(slides): move explicit definition of Regression Model to slide 4 and restore slide 3
</commit_message>
<xml_diff>
--- a/presentation/slides_apresentacao.pptx
+++ b/presentation/slides_apresentacao.pptx
@@ -3675,7 +3675,7 @@
               </a:defRPr>
             </a:pPr>
             <a:r>
-              <a:t>2. Formulação Matemática: Modelos de Regressão &amp; Perdas L2 vs. L1</a:t>
+              <a:t>2. Formulação Matemática: Funções de Perda L2 vs. L1</a:t>
             </a:r>
           </a:p>
           <a:p>
@@ -3690,7 +3690,191 @@
               </a:defRPr>
             </a:pPr>
             <a:r>
-              <a:t>Conceito Fundamental, Otimização Paramétrica e Comportamento dos Erros no Python</a:t>
+              <a:t>Otimização Paramétrica e Comportamento dos Erros no Sistema em Python</a:t>
+            </a:r>
+          </a:p>
+        </p:txBody>
+      </p:sp>
+      <p:sp>
+        <p:nvSpPr>
+          <p:cNvPr id="3" name="TextBox 2"/>
+          <p:cNvSpPr txBox="1"/>
+          <p:nvPr/>
+        </p:nvSpPr>
+        <p:spPr>
+          <a:xfrm>
+            <a:off x="731520" y="1645920"/>
+            <a:ext cx="10698480" cy="4572000"/>
+          </a:xfrm>
+          <a:prstGeom prst="rect">
+            <a:avLst/>
+          </a:prstGeom>
+          <a:noFill/>
+        </p:spPr>
+        <p:txBody>
+          <a:bodyPr wrap="square">
+            <a:spAutoFit/>
+          </a:bodyPr>
+          <a:lstStyle/>
+          <a:p/>
+          <a:p>
+            <a:pPr>
+              <a:spcBef>
+                <a:spcPts val="800"/>
+              </a:spcBef>
+            </a:pPr>
+            <a:r>
+              <a:rPr b="1" sz="1300">
+                <a:solidFill>
+                  <a:srgbClr val="0F172A"/>
+                </a:solidFill>
+              </a:rPr>
+              <a:t>Variáveis Físicas do Modelo (CMU Item 5):</a:t>
+            </a:r>
+            <a:r>
+              <a:rPr sz="1250">
+                <a:solidFill>
+                  <a:srgbClr val="334155"/>
+                </a:solidFill>
+              </a:rPr>
+              <a:t> Entrada (x): Temperatura máxima diária em graus Celsius (°C). Alvo (y): Pico diário de demanda da concessionária em Gigawatts (GW). Histórico: N = 1.460 dias observados.</a:t>
+            </a:r>
+          </a:p>
+          <a:p>
+            <a:pPr>
+              <a:spcBef>
+                <a:spcPts val="800"/>
+              </a:spcBef>
+            </a:pPr>
+            <a:r>
+              <a:rPr b="1" sz="1300">
+                <a:solidFill>
+                  <a:srgbClr val="0F172A"/>
+                </a:solidFill>
+              </a:rPr>
+              <a:t>Perda Quadrática (L2 — Mínimos Quadrados / Squared Loss):</a:t>
+            </a:r>
+            <a:r>
+              <a:rPr sz="1250">
+                <a:solidFill>
+                  <a:srgbClr val="334155"/>
+                </a:solidFill>
+              </a:rPr>
+              <a:t> J(θ) = Σ (y_i - φ(x_i) θ)². Resolvida no Python por Equação Normal analítica: θ = (Φᵀ Φ)⁻¹ Φᵀ y. Supõe distribuição normal de ruídos; pune severamente erros grandes, sendo puxada para baixo por feriados ou quedas pontuais de carga.</a:t>
+            </a:r>
+          </a:p>
+          <a:p>
+            <a:pPr>
+              <a:spcBef>
+                <a:spcPts val="800"/>
+              </a:spcBef>
+            </a:pPr>
+            <a:r>
+              <a:rPr b="1" sz="1300">
+                <a:solidFill>
+                  <a:srgbClr val="0F172A"/>
+                </a:solidFill>
+              </a:rPr>
+              <a:t>Perda Absoluta (L1 — LAD Robusta / Absolute Loss):</a:t>
+            </a:r>
+            <a:r>
+              <a:rPr sz="1250">
+                <a:solidFill>
+                  <a:srgbClr val="334155"/>
+                </a:solidFill>
+              </a:rPr>
+              <a:t> J(θ) = Σ |y_i - φ(x_i) θ|. Otimiza a MEDIANA condicional (distribuição Laplace). Resolvida no Python por otimização convexa direta (scipy via Powell). Extremamente robusta a desvios e quedas anômalas, traçando a curva da demanda típica.</a:t>
+            </a:r>
+          </a:p>
+          <a:p>
+            <a:pPr>
+              <a:spcBef>
+                <a:spcPts val="800"/>
+              </a:spcBef>
+            </a:pPr>
+            <a:r>
+              <a:rPr b="1" sz="1300">
+                <a:solidFill>
+                  <a:srgbClr val="0F172A"/>
+                </a:solidFill>
+              </a:rPr>
+              <a:t>Regularização Ridge (L2 Shrinkage com λ = 10⁻⁴):</a:t>
+            </a:r>
+            <a:r>
+              <a:rPr sz="1250">
+                <a:solidFill>
+                  <a:srgbClr val="334155"/>
+                </a:solidFill>
+              </a:rPr>
+              <a:t> Adiciona penalidade λ ||θ||² na função objetivo para restringir a norma dos pesos e evitar sobreajuste (overfitting) em transformações de alta dimensão.</a:t>
+            </a:r>
+          </a:p>
+        </p:txBody>
+      </p:sp>
+    </p:spTree>
+  </p:cSld>
+  <p:clrMapOvr>
+    <a:masterClrMapping/>
+  </p:clrMapOvr>
+</p:sld>
+</file>
+
+<file path=ppt/slides/slide4.xml><?xml version="1.0" encoding="utf-8"?>
+<p:sld xmlns:a="http://schemas.openxmlformats.org/drawingml/2006/main" xmlns:p="http://schemas.openxmlformats.org/presentationml/2006/main" xmlns:r="http://schemas.openxmlformats.org/officeDocument/2006/relationships">
+  <p:cSld>
+    <p:spTree>
+      <p:nvGrpSpPr>
+        <p:cNvPr id="1" name=""/>
+        <p:cNvGrpSpPr/>
+        <p:nvPr/>
+      </p:nvGrpSpPr>
+      <p:grpSpPr/>
+      <p:sp>
+        <p:nvSpPr>
+          <p:cNvPr id="2" name="TextBox 1"/>
+          <p:cNvSpPr txBox="1"/>
+          <p:nvPr/>
+        </p:nvSpPr>
+        <p:spPr>
+          <a:xfrm>
+            <a:off x="731520" y="457200"/>
+            <a:ext cx="10698480" cy="1097280"/>
+          </a:xfrm>
+          <a:prstGeom prst="rect">
+            <a:avLst/>
+          </a:prstGeom>
+          <a:noFill/>
+        </p:spPr>
+        <p:txBody>
+          <a:bodyPr wrap="square">
+            <a:spAutoFit/>
+          </a:bodyPr>
+          <a:lstStyle/>
+          <a:p>
+            <a:pPr>
+              <a:defRPr sz="2600" b="1">
+                <a:solidFill>
+                  <a:srgbClr val="0F172A"/>
+                </a:solidFill>
+              </a:defRPr>
+            </a:pPr>
+            <a:r>
+              <a:t>3. Arquitetura dos 4 Modelos de Regressão</a:t>
+            </a:r>
+          </a:p>
+          <a:p>
+            <a:pPr>
+              <a:spcBef>
+                <a:spcPts val="400"/>
+              </a:spcBef>
+              <a:defRPr sz="1300">
+                <a:solidFill>
+                  <a:srgbClr val="2563EB"/>
+                </a:solidFill>
+              </a:defRPr>
+            </a:pPr>
+            <a:r>
+              <a:t>CMU 15-884 (Item 5) – Capacidade de Modelagem e Resposta Térmica</a:t>
             </a:r>
           </a:p>
         </p:txBody>
@@ -3704,7 +3888,7 @@
         <p:spPr>
           <a:xfrm>
             <a:off x="731520" y="1554480"/>
-            <a:ext cx="10728655" cy="1280160"/>
+            <a:ext cx="10728655" cy="1097280"/>
           </a:xfrm>
           <a:prstGeom prst="roundRect">
             <a:avLst/>
@@ -3712,7 +3896,7 @@
           <a:solidFill>
             <a:srgbClr val="EFF6FF"/>
           </a:solidFill>
-          <a:ln w="19050">
+          <a:ln w="15240">
             <a:solidFill>
               <a:srgbClr val="2563EB"/>
             </a:solidFill>
@@ -3733,11 +3917,11 @@
           </a:fontRef>
         </p:style>
         <p:txBody>
-          <a:bodyPr rtlCol="0" anchor="ctr" wrap="square" tIns="109728" bIns="91440" lIns="182880" rIns="182880"/>
+          <a:bodyPr rtlCol="0" anchor="ctr" wrap="square" tIns="91440" bIns="73152" lIns="164592" rIns="164592"/>
           <a:lstStyle/>
           <a:p>
             <a:pPr algn="ctr">
-              <a:defRPr b="1" sz="1300">
+              <a:defRPr b="1" sz="1250">
                 <a:solidFill>
                   <a:srgbClr val="0F172A"/>
                 </a:solidFill>
@@ -3752,7 +3936,7 @@
               <a:spcBef>
                 <a:spcPts val="300"/>
               </a:spcBef>
-              <a:defRPr sz="1150">
+              <a:defRPr sz="1100">
                 <a:solidFill>
                   <a:srgbClr val="334155"/>
                 </a:solidFill>
@@ -3762,374 +3946,18 @@
               <a:t>É uma técnica estatística e de aprendizado de máquina (Machine Learning) usada para investigar a relação entre uma variável dependente (o desfecho ou valor que queremos prever) e uma ou mais variáveis independentes (os preditores ou características).</a:t>
             </a:r>
           </a:p>
-          <a:p>
-            <a:pPr>
-              <a:spcBef>
-                <a:spcPts val="300"/>
-              </a:spcBef>
-            </a:pPr>
-            <a:r>
-              <a:rPr b="1" sz="1050">
-                <a:solidFill>
-                  <a:srgbClr val="2563EB"/>
-                </a:solidFill>
-              </a:rPr>
-              <a:t>➔ Aplicação no Sistema (CMU Item 5): </a:t>
-            </a:r>
-            <a:r>
-              <a:rPr sz="1050">
-                <a:solidFill>
-                  <a:srgbClr val="334155"/>
-                </a:solidFill>
-              </a:rPr>
-              <a:t>Variável Dependente (y): Pico diário de demanda da rede em GW | Variável Independente (x): Temperatura máxima diária em °C | Amostras: N = 1.460 dias.</a:t>
-            </a:r>
-          </a:p>
-        </p:txBody>
-      </p:sp>
-      <p:sp>
-        <p:nvSpPr>
-          <p:cNvPr id="4" name="Rounded Rectangle 3"/>
-          <p:cNvSpPr/>
+        </p:txBody>
+      </p:sp>
+      <p:sp>
+        <p:nvSpPr>
+          <p:cNvPr id="4" name="TextBox 3"/>
+          <p:cNvSpPr txBox="1"/>
           <p:nvPr/>
         </p:nvSpPr>
         <p:spPr>
           <a:xfrm>
-            <a:off x="731520" y="2971800"/>
-            <a:ext cx="5212080" cy="3337560"/>
-          </a:xfrm>
-          <a:prstGeom prst="roundRect">
-            <a:avLst/>
-          </a:prstGeom>
-          <a:solidFill>
-            <a:srgbClr val="F8FAFC"/>
-          </a:solidFill>
-          <a:ln w="12700">
-            <a:solidFill>
-              <a:srgbClr val="CBD5E1"/>
-            </a:solidFill>
-          </a:ln>
-        </p:spPr>
-        <p:style>
-          <a:lnRef idx="1">
-            <a:schemeClr val="accent1"/>
-          </a:lnRef>
-          <a:fillRef idx="3">
-            <a:schemeClr val="accent1"/>
-          </a:fillRef>
-          <a:effectRef idx="2">
-            <a:schemeClr val="accent1"/>
-          </a:effectRef>
-          <a:fontRef idx="minor">
-            <a:schemeClr val="lt1"/>
-          </a:fontRef>
-        </p:style>
-        <p:txBody>
-          <a:bodyPr rtlCol="0" anchor="ctr" wrap="square" tIns="109728" bIns="91440" lIns="164592" rIns="164592"/>
-          <a:lstStyle/>
-          <a:p>
-            <a:pPr algn="ctr">
-              <a:defRPr b="1" sz="1200">
-                <a:solidFill>
-                  <a:srgbClr val="0F172A"/>
-                </a:solidFill>
-              </a:defRPr>
-            </a:pPr>
-            <a:r>
-              <a:t>Perda Quadrática (L2 — Mínimos Quadrados / OLS)</a:t>
-            </a:r>
-          </a:p>
-          <a:p>
-            <a:pPr>
-              <a:spcBef>
-                <a:spcPts val="400"/>
-              </a:spcBef>
-            </a:pPr>
-            <a:r>
-              <a:rPr b="1" sz="1000">
-                <a:solidFill>
-                  <a:srgbClr val="2563EB"/>
-                </a:solidFill>
-              </a:rPr>
-              <a:t>Função Objetivo: </a:t>
-            </a:r>
-            <a:r>
-              <a:rPr sz="1000">
-                <a:solidFill>
-                  <a:srgbClr val="334155"/>
-                </a:solidFill>
-              </a:rPr>
-              <a:t>J(θ) = Σ (y_i - φ(x_i) θ)². Minimiza o erro quadrático médio em toda a amostra.</a:t>
-            </a:r>
-          </a:p>
-          <a:p>
-            <a:pPr>
-              <a:spcBef>
-                <a:spcPts val="400"/>
-              </a:spcBef>
-            </a:pPr>
-            <a:r>
-              <a:rPr b="1" sz="1000">
-                <a:solidFill>
-                  <a:srgbClr val="2563EB"/>
-                </a:solidFill>
-              </a:rPr>
-              <a:t>Solução no Python: </a:t>
-            </a:r>
-            <a:r>
-              <a:rPr sz="1000">
-                <a:solidFill>
-                  <a:srgbClr val="334155"/>
-                </a:solidFill>
-              </a:rPr>
-              <a:t>Equação Normal analítica exata: θ = (Φᵀ Φ)⁻¹ Φᵀ y, executada com alta velocidade.</a:t>
-            </a:r>
-          </a:p>
-          <a:p>
-            <a:pPr>
-              <a:spcBef>
-                <a:spcPts val="400"/>
-              </a:spcBef>
-            </a:pPr>
-            <a:r>
-              <a:rPr b="1" sz="1000">
-                <a:solidFill>
-                  <a:srgbClr val="2563EB"/>
-                </a:solidFill>
-              </a:rPr>
-              <a:t>Comportamento Estatístico: </a:t>
-            </a:r>
-            <a:r>
-              <a:rPr sz="1000">
-                <a:solidFill>
-                  <a:srgbClr val="334155"/>
-                </a:solidFill>
-              </a:rPr>
-              <a:t>Estima a MÉDIA condicional da demanda dada a temperatura (distribuição Gaussiana).</a:t>
-            </a:r>
-          </a:p>
-          <a:p>
-            <a:pPr>
-              <a:spcBef>
-                <a:spcPts val="400"/>
-              </a:spcBef>
-            </a:pPr>
-            <a:r>
-              <a:rPr b="1" sz="1000">
-                <a:solidFill>
-                  <a:srgbClr val="2563EB"/>
-                </a:solidFill>
-              </a:rPr>
-              <a:t>Sensibilidade a Outliers: </a:t>
-            </a:r>
-            <a:r>
-              <a:rPr sz="1000">
-                <a:solidFill>
-                  <a:srgbClr val="334155"/>
-                </a:solidFill>
-              </a:rPr>
-              <a:t>Por elevar os erros ao quadrado, a curva é puxada para baixo por dias com quedas atípicas de consumo (feriados, pontes e paradas pontuais da rede).</a:t>
-            </a:r>
-          </a:p>
-        </p:txBody>
-      </p:sp>
-      <p:sp>
-        <p:nvSpPr>
-          <p:cNvPr id="5" name="Rounded Rectangle 4"/>
-          <p:cNvSpPr/>
-          <p:nvPr/>
-        </p:nvSpPr>
-        <p:spPr>
-          <a:xfrm>
-            <a:off x="6248095" y="2971800"/>
-            <a:ext cx="5212080" cy="3337560"/>
-          </a:xfrm>
-          <a:prstGeom prst="roundRect">
-            <a:avLst/>
-          </a:prstGeom>
-          <a:solidFill>
-            <a:srgbClr val="F8FAFC"/>
-          </a:solidFill>
-          <a:ln w="12700">
-            <a:solidFill>
-              <a:srgbClr val="CBD5E1"/>
-            </a:solidFill>
-          </a:ln>
-        </p:spPr>
-        <p:style>
-          <a:lnRef idx="1">
-            <a:schemeClr val="accent1"/>
-          </a:lnRef>
-          <a:fillRef idx="3">
-            <a:schemeClr val="accent1"/>
-          </a:fillRef>
-          <a:effectRef idx="2">
-            <a:schemeClr val="accent1"/>
-          </a:effectRef>
-          <a:fontRef idx="minor">
-            <a:schemeClr val="lt1"/>
-          </a:fontRef>
-        </p:style>
-        <p:txBody>
-          <a:bodyPr rtlCol="0" anchor="ctr" wrap="square" tIns="109728" bIns="91440" lIns="164592" rIns="164592"/>
-          <a:lstStyle/>
-          <a:p>
-            <a:pPr algn="ctr">
-              <a:defRPr b="1" sz="1200">
-                <a:solidFill>
-                  <a:srgbClr val="0F172A"/>
-                </a:solidFill>
-              </a:defRPr>
-            </a:pPr>
-            <a:r>
-              <a:t>Perda Absoluta (L1 — LAD Robusta / Powell)</a:t>
-            </a:r>
-          </a:p>
-          <a:p>
-            <a:pPr>
-              <a:spcBef>
-                <a:spcPts val="350"/>
-              </a:spcBef>
-            </a:pPr>
-            <a:r>
-              <a:rPr b="1" sz="950">
-                <a:solidFill>
-                  <a:srgbClr val="2563EB"/>
-                </a:solidFill>
-              </a:rPr>
-              <a:t>Função Objetivo: </a:t>
-            </a:r>
-            <a:r>
-              <a:rPr sz="950">
-                <a:solidFill>
-                  <a:srgbClr val="334155"/>
-                </a:solidFill>
-              </a:rPr>
-              <a:t>J(θ) = Σ |y_i - φ(x_i) θ|. Penaliza os desvios de forma linear e proporcional.</a:t>
-            </a:r>
-          </a:p>
-          <a:p>
-            <a:pPr>
-              <a:spcBef>
-                <a:spcPts val="350"/>
-              </a:spcBef>
-            </a:pPr>
-            <a:r>
-              <a:rPr b="1" sz="950">
-                <a:solidFill>
-                  <a:srgbClr val="2563EB"/>
-                </a:solidFill>
-              </a:rPr>
-              <a:t>Solução no Python: </a:t>
-            </a:r>
-            <a:r>
-              <a:rPr sz="950">
-                <a:solidFill>
-                  <a:srgbClr val="334155"/>
-                </a:solidFill>
-              </a:rPr>
-              <a:t>Otimização numérica via scipy.optimize.minimize com método Powell (sem derivada).</a:t>
-            </a:r>
-          </a:p>
-          <a:p>
-            <a:pPr>
-              <a:spcBef>
-                <a:spcPts val="350"/>
-              </a:spcBef>
-            </a:pPr>
-            <a:r>
-              <a:rPr b="1" sz="950">
-                <a:solidFill>
-                  <a:srgbClr val="2563EB"/>
-                </a:solidFill>
-              </a:rPr>
-              <a:t>Comportamento Estatístico: </a:t>
-            </a:r>
-            <a:r>
-              <a:rPr sz="950">
-                <a:solidFill>
-                  <a:srgbClr val="334155"/>
-                </a:solidFill>
-              </a:rPr>
-              <a:t>Estima a MEDIANA condicional da demanda (associada à distribuição de Laplace).</a:t>
-            </a:r>
-          </a:p>
-          <a:p>
-            <a:pPr>
-              <a:spcBef>
-                <a:spcPts val="350"/>
-              </a:spcBef>
-            </a:pPr>
-            <a:r>
-              <a:rPr b="1" sz="950">
-                <a:solidFill>
-                  <a:srgbClr val="2563EB"/>
-                </a:solidFill>
-              </a:rPr>
-              <a:t>Máxima Robustez Física: </a:t>
-            </a:r>
-            <a:r>
-              <a:rPr sz="950">
-                <a:solidFill>
-                  <a:srgbClr val="334155"/>
-                </a:solidFill>
-              </a:rPr>
-              <a:t>Ignora quedas atípicas de feriados; traça o consumo típico e fica ligeiramente ACIMA de L2 no gráfico, refletindo os dias de operação plena da rede.</a:t>
-            </a:r>
-          </a:p>
-          <a:p>
-            <a:pPr>
-              <a:spcBef>
-                <a:spcPts val="350"/>
-              </a:spcBef>
-            </a:pPr>
-            <a:r>
-              <a:rPr b="1" sz="950">
-                <a:solidFill>
-                  <a:srgbClr val="2563EB"/>
-                </a:solidFill>
-              </a:rPr>
-              <a:t>Regularização Ridge (λ = 10⁻⁴): </a:t>
-            </a:r>
-            <a:r>
-              <a:rPr sz="950">
-                <a:solidFill>
-                  <a:srgbClr val="334155"/>
-                </a:solidFill>
-              </a:rPr>
-              <a:t>Penalidade λ ||θ||² incluída para evitar sobreajuste em matrizes de alta dimensão.</a:t>
-            </a:r>
-          </a:p>
-        </p:txBody>
-      </p:sp>
-    </p:spTree>
-  </p:cSld>
-  <p:clrMapOvr>
-    <a:masterClrMapping/>
-  </p:clrMapOvr>
-</p:sld>
-</file>
-
-<file path=ppt/slides/slide4.xml><?xml version="1.0" encoding="utf-8"?>
-<p:sld xmlns:a="http://schemas.openxmlformats.org/drawingml/2006/main" xmlns:p="http://schemas.openxmlformats.org/presentationml/2006/main" xmlns:r="http://schemas.openxmlformats.org/officeDocument/2006/relationships">
-  <p:cSld>
-    <p:spTree>
-      <p:nvGrpSpPr>
-        <p:cNvPr id="1" name=""/>
-        <p:cNvGrpSpPr/>
-        <p:nvPr/>
-      </p:nvGrpSpPr>
-      <p:grpSpPr/>
-      <p:sp>
-        <p:nvSpPr>
-          <p:cNvPr id="2" name="TextBox 1"/>
-          <p:cNvSpPr txBox="1"/>
-          <p:nvPr/>
-        </p:nvSpPr>
-        <p:spPr>
-          <a:xfrm>
-            <a:off x="731520" y="457200"/>
-            <a:ext cx="10698480" cy="1097280"/>
+            <a:off x="731520" y="2788920"/>
+            <a:ext cx="10728655" cy="3657600"/>
           </a:xfrm>
           <a:prstGeom prst="rect">
             <a:avLst/>
@@ -4142,141 +3970,85 @@
           </a:bodyPr>
           <a:lstStyle/>
           <a:p>
-            <a:pPr>
-              <a:defRPr sz="2600" b="1">
+            <a:r>
+              <a:rPr b="1" sz="1200">
                 <a:solidFill>
                   <a:srgbClr val="0F172A"/>
                 </a:solidFill>
-              </a:defRPr>
-            </a:pPr>
-            <a:r>
-              <a:t>3. Arquitetura dos 4 Modelos de Regressão</a:t>
+              </a:rPr>
+              <a:t>1. Linear Simples [φ(x) = [1, x]]:</a:t>
+            </a:r>
+            <a:r>
+              <a:rPr sz="1150">
+                <a:solidFill>
+                  <a:srgbClr val="334155"/>
+                </a:solidFill>
+              </a:rPr>
+              <a:t> Linha reta rígida com pesos θ ∈ ℝ². Falha na física do problema (R² = 0.116), pois supõe erroneamente que frio e calor agem na mesma direção sobre o consumo.</a:t>
             </a:r>
           </a:p>
           <a:p>
             <a:pPr>
               <a:spcBef>
-                <a:spcPts val="400"/>
+                <a:spcPts val="600"/>
               </a:spcBef>
-              <a:defRPr sz="1300">
-                <a:solidFill>
-                  <a:srgbClr val="2563EB"/>
-                </a:solidFill>
-              </a:defRPr>
-            </a:pPr>
-            <a:r>
-              <a:t>CMU 15-884 (Item 5) – Capacidade de Modelagem e Resposta Térmica</a:t>
-            </a:r>
-          </a:p>
-        </p:txBody>
-      </p:sp>
-      <p:sp>
-        <p:nvSpPr>
-          <p:cNvPr id="3" name="TextBox 2"/>
-          <p:cNvSpPr txBox="1"/>
-          <p:nvPr/>
-        </p:nvSpPr>
-        <p:spPr>
-          <a:xfrm>
-            <a:off x="731520" y="1645920"/>
-            <a:ext cx="10698480" cy="4572000"/>
-          </a:xfrm>
-          <a:prstGeom prst="rect">
-            <a:avLst/>
-          </a:prstGeom>
-          <a:noFill/>
-        </p:spPr>
-        <p:txBody>
-          <a:bodyPr wrap="square">
-            <a:spAutoFit/>
-          </a:bodyPr>
-          <a:lstStyle/>
-          <a:p/>
+            </a:pPr>
+            <a:r>
+              <a:rPr b="1" sz="1200">
+                <a:solidFill>
+                  <a:srgbClr val="0F172A"/>
+                </a:solidFill>
+              </a:rPr>
+              <a:t>2. Polinomial [φ(x) = [1, x, x², x³, x⁴, x⁵]]:</a:t>
+            </a:r>
+            <a:r>
+              <a:rPr sz="1150">
+                <a:solidFill>
+                  <a:srgbClr val="334155"/>
+                </a:solidFill>
+              </a:rPr>
+              <a:t> Curva contínua suave com pesos θ ∈ ℝ⁶. Modela a elevação no frio e no calor (R² salta para 0.715). Ponto fraco: vulnerabilidade a oscilações em extremos térmicos.</a:t>
+            </a:r>
+          </a:p>
           <a:p>
             <a:pPr>
               <a:spcBef>
-                <a:spcPts val="800"/>
+                <a:spcPts val="600"/>
               </a:spcBef>
             </a:pPr>
             <a:r>
-              <a:rPr b="1" sz="1300">
+              <a:rPr b="1" sz="1200">
                 <a:solidFill>
                   <a:srgbClr val="0F172A"/>
                 </a:solidFill>
               </a:rPr>
-              <a:t>1. Linear Simples [φ(x) = [1, x]]:</a:t>
-            </a:r>
-            <a:r>
-              <a:rPr sz="1250">
+              <a:t>3. Funções de Base Radial (RBF Local):</a:t>
+            </a:r>
+            <a:r>
+              <a:rPr sz="1150">
                 <a:solidFill>
                   <a:srgbClr val="334155"/>
                 </a:solidFill>
               </a:rPr>
-              <a:t> Linha reta rígida com pesos θ ∈ ℝ². Falha na física do problema (R² = 0.116), pois supõe erroneamente que frio e calor agem na mesma direção sobre o consumo.</a:t>
+              <a:t> 5 centros fixos distribuídos na faixa térmica μ = [-6,7; 4,4; 15,6; 26,7; 37,8]°C com dispersão σ ≈ 11,1°C. φ_j(x) = exp(-(x - μ_j)² / (2σ²)). Sinos gaussianos que capturam comportamentos locais sem instabilidade nas bordas (R² = 0.713).</a:t>
             </a:r>
           </a:p>
           <a:p>
             <a:pPr>
               <a:spcBef>
-                <a:spcPts val="800"/>
+                <a:spcPts val="600"/>
               </a:spcBef>
             </a:pPr>
             <a:r>
-              <a:rPr b="1" sz="1300">
+              <a:rPr b="1" sz="1200">
                 <a:solidFill>
                   <a:srgbClr val="0F172A"/>
                 </a:solidFill>
               </a:rPr>
-              <a:t>2. Polinomial [φ(x) = [1, x, x², x³, x⁴, x⁵]]:</a:t>
-            </a:r>
-            <a:r>
-              <a:rPr sz="1250">
-                <a:solidFill>
-                  <a:srgbClr val="334155"/>
-                </a:solidFill>
-              </a:rPr>
-              <a:t> Curva contínua suave com pesos θ ∈ ℝ⁶. Modela a elevação no frio e no calor (R² salta para 0.715). Ponto fraco: vulnerabilidade a oscilações em extremos térmicos.</a:t>
-            </a:r>
-          </a:p>
-          <a:p>
-            <a:pPr>
-              <a:spcBef>
-                <a:spcPts val="800"/>
-              </a:spcBef>
-            </a:pPr>
-            <a:r>
-              <a:rPr b="1" sz="1300">
-                <a:solidFill>
-                  <a:srgbClr val="0F172A"/>
-                </a:solidFill>
-              </a:rPr>
-              <a:t>3. Funções de Base Radial (RBF Local):</a:t>
-            </a:r>
-            <a:r>
-              <a:rPr sz="1250">
-                <a:solidFill>
-                  <a:srgbClr val="334155"/>
-                </a:solidFill>
-              </a:rPr>
-              <a:t> 5 centros fixos distribuídos na faixa térmica μ = [-6,7; 4,4; 15,6; 26,7; 37,8]°C com dispersão σ ≈ 11,1°C. φ_j(x) = exp(-(x - μ_j)² / (2σ²)). Sinos gaussianos que capturam comportamentos locais sem instabilidade nas bordas (R² = 0.713).</a:t>
-            </a:r>
-          </a:p>
-          <a:p>
-            <a:pPr>
-              <a:spcBef>
-                <a:spcPts val="800"/>
-              </a:spcBef>
-            </a:pPr>
-            <a:r>
-              <a:rPr b="1" sz="1300">
-                <a:solidFill>
-                  <a:srgbClr val="0F172A"/>
-                </a:solidFill>
-              </a:rPr>
               <a:t>4. Kernel Gaussiano com Ridge (Dual, λ = 10⁻⁴):</a:t>
             </a:r>
             <a:r>
-              <a:rPr sz="1250">
+              <a:rPr sz="1150">
                 <a:solidFill>
                   <a:srgbClr val="334155"/>
                 </a:solidFill>

</xml_diff>